<commit_message>
style(ppt): enlarge font sizes and remove rubric marks annotations
</commit_message>
<xml_diff>
--- a/docs/AI_News_Credibility_Scorer_Review2.pptx
+++ b/docs/AI_News_Credibility_Scorer_Review2.pptx
@@ -12282,7 +12282,7 @@
         <p:spPr>
           <a:xfrm>
             <a:off x="731520" y="365760"/>
-            <a:ext cx="10515600" cy="822960"/>
+            <a:ext cx="10789920" cy="822960"/>
           </a:xfrm>
           <a:prstGeom prst="rect">
             <a:avLst/>
@@ -12296,7 +12296,7 @@
           <a:lstStyle/>
           <a:p>
             <a:pPr>
-              <a:defRPr sz="2400" b="1">
+              <a:defRPr sz="2600" b="1">
                 <a:solidFill>
                   <a:srgbClr val="102C57"/>
                 </a:solidFill>
@@ -12304,7 +12304,7 @@
               </a:defRPr>
             </a:pPr>
             <a:r>
-              <a:t>Proposed Method &amp; Feasibility Study (Rubric: 3 Marks)</a:t>
+              <a:t>Proposed Method &amp; Feasibility Study</a:t>
             </a:r>
           </a:p>
         </p:txBody>
@@ -12318,7 +12318,7 @@
         <p:spPr>
           <a:xfrm>
             <a:off x="731520" y="1188720"/>
-            <a:ext cx="10515600" cy="5120640"/>
+            <a:ext cx="10789920" cy="5120640"/>
           </a:xfrm>
           <a:prstGeom prst="rect">
             <a:avLst/>
@@ -12337,7 +12337,7 @@
               </a:spcAft>
             </a:pPr>
             <a:r>
-              <a:rPr b="1" sz="1300">
+              <a:rPr b="1" sz="1400">
                 <a:solidFill>
                   <a:srgbClr val="102C57"/>
                 </a:solidFill>
@@ -12352,7 +12352,7 @@
               </a:spcAft>
             </a:pPr>
             <a:r>
-              <a:rPr sz="1100">
+              <a:rPr sz="1200">
                 <a:solidFill>
                   <a:srgbClr val="212529"/>
                 </a:solidFill>
@@ -12365,11 +12365,11 @@
           <a:p>
             <a:pPr>
               <a:spcAft>
-                <a:spcPts val="400"/>
+                <a:spcPts val="500"/>
               </a:spcAft>
             </a:pPr>
             <a:r>
-              <a:rPr b="1" sz="1100">
+              <a:rPr b="1" sz="1250">
                 <a:solidFill>
                   <a:srgbClr val="3565A9"/>
                 </a:solidFill>
@@ -12377,7 +12377,7 @@
               <a:t>1. Technical Feasibility: </a:t>
             </a:r>
             <a:r>
-              <a:rPr sz="1100">
+              <a:rPr sz="1250">
                 <a:solidFill>
                   <a:srgbClr val="212529"/>
                 </a:solidFill>
@@ -12388,11 +12388,11 @@
           <a:p>
             <a:pPr>
               <a:spcAft>
-                <a:spcPts val="400"/>
+                <a:spcPts val="500"/>
               </a:spcAft>
             </a:pPr>
             <a:r>
-              <a:rPr b="1" sz="1100">
+              <a:rPr b="1" sz="1250">
                 <a:solidFill>
                   <a:srgbClr val="3565A9"/>
                 </a:solidFill>
@@ -12400,7 +12400,7 @@
               <a:t>2. Economic / Cost Feasibility ($0 Cost): </a:t>
             </a:r>
             <a:r>
-              <a:rPr sz="1100">
+              <a:rPr sz="1250">
                 <a:solidFill>
                   <a:srgbClr val="212529"/>
                 </a:solidFill>
@@ -12411,11 +12411,11 @@
           <a:p>
             <a:pPr>
               <a:spcAft>
-                <a:spcPts val="400"/>
+                <a:spcPts val="500"/>
               </a:spcAft>
             </a:pPr>
             <a:r>
-              <a:rPr b="1" sz="1100">
+              <a:rPr b="1" sz="1250">
                 <a:solidFill>
                   <a:srgbClr val="3565A9"/>
                 </a:solidFill>
@@ -12423,7 +12423,7 @@
               <a:t>3. Computational Feasibility: </a:t>
             </a:r>
             <a:r>
-              <a:rPr sz="1100">
+              <a:rPr sz="1250">
                 <a:solidFill>
                   <a:srgbClr val="212529"/>
                 </a:solidFill>
@@ -12434,11 +12434,11 @@
           <a:p>
             <a:pPr>
               <a:spcAft>
-                <a:spcPts val="400"/>
+                <a:spcPts val="500"/>
               </a:spcAft>
             </a:pPr>
             <a:r>
-              <a:rPr b="1" sz="1100">
+              <a:rPr b="1" sz="1250">
                 <a:solidFill>
                   <a:srgbClr val="3565A9"/>
                 </a:solidFill>
@@ -12446,7 +12446,7 @@
               <a:t>4. Resource Availability: </a:t>
             </a:r>
             <a:r>
-              <a:rPr sz="1100">
+              <a:rPr sz="1250">
                 <a:solidFill>
                   <a:srgbClr val="212529"/>
                 </a:solidFill>
@@ -12490,7 +12490,7 @@
         <p:spPr>
           <a:xfrm>
             <a:off x="731520" y="365760"/>
-            <a:ext cx="10515600" cy="822960"/>
+            <a:ext cx="10789920" cy="822960"/>
           </a:xfrm>
           <a:prstGeom prst="rect">
             <a:avLst/>
@@ -12504,7 +12504,7 @@
           <a:lstStyle/>
           <a:p>
             <a:pPr>
-              <a:defRPr sz="2400" b="1">
+              <a:defRPr sz="2600" b="1">
                 <a:solidFill>
                   <a:srgbClr val="102C57"/>
                 </a:solidFill>
@@ -12512,7 +12512,7 @@
               </a:defRPr>
             </a:pPr>
             <a:r>
-              <a:t>System Architecture Diagram (Rubric: 3 Marks)</a:t>
+              <a:t>System Architecture Diagram</a:t>
             </a:r>
           </a:p>
         </p:txBody>
@@ -12562,7 +12562,7 @@
               <a:spcAft>
                 <a:spcPts val="600"/>
               </a:spcAft>
-              <a:defRPr sz="1200" b="1">
+              <a:defRPr sz="1300" b="1">
                 <a:solidFill>
                   <a:srgbClr val="102C57"/>
                 </a:solidFill>
@@ -12576,9 +12576,9 @@
           <a:p>
             <a:pPr>
               <a:spcAft>
-                <a:spcPts val="200"/>
-              </a:spcAft>
-              <a:defRPr sz="1000" b="1">
+                <a:spcPts val="250"/>
+              </a:spcAft>
+              <a:defRPr sz="1100" b="1">
                 <a:solidFill>
                   <a:srgbClr val="102C57"/>
                 </a:solidFill>
@@ -12592,9 +12592,9 @@
           <a:p>
             <a:pPr>
               <a:spcAft>
-                <a:spcPts val="200"/>
-              </a:spcAft>
-              <a:defRPr sz="1000" b="0">
+                <a:spcPts val="250"/>
+              </a:spcAft>
+              <a:defRPr sz="1100" b="0">
                 <a:solidFill>
                   <a:srgbClr val="212529"/>
                 </a:solidFill>
@@ -12608,9 +12608,9 @@
           <a:p>
             <a:pPr>
               <a:spcAft>
-                <a:spcPts val="200"/>
-              </a:spcAft>
-              <a:defRPr sz="1000" b="0">
+                <a:spcPts val="250"/>
+              </a:spcAft>
+              <a:defRPr sz="1100" b="0">
                 <a:solidFill>
                   <a:srgbClr val="212529"/>
                 </a:solidFill>
@@ -12624,9 +12624,9 @@
           <a:p>
             <a:pPr>
               <a:spcAft>
-                <a:spcPts val="200"/>
-              </a:spcAft>
-              <a:defRPr sz="1000" b="0">
+                <a:spcPts val="250"/>
+              </a:spcAft>
+              <a:defRPr sz="1100" b="0">
                 <a:solidFill>
                   <a:srgbClr val="212529"/>
                 </a:solidFill>
@@ -12637,9 +12637,9 @@
           <a:p>
             <a:pPr>
               <a:spcAft>
-                <a:spcPts val="200"/>
-              </a:spcAft>
-              <a:defRPr sz="1000" b="1">
+                <a:spcPts val="250"/>
+              </a:spcAft>
+              <a:defRPr sz="1100" b="1">
                 <a:solidFill>
                   <a:srgbClr val="102C57"/>
                 </a:solidFill>
@@ -12653,9 +12653,9 @@
           <a:p>
             <a:pPr>
               <a:spcAft>
-                <a:spcPts val="200"/>
-              </a:spcAft>
-              <a:defRPr sz="1000" b="0">
+                <a:spcPts val="250"/>
+              </a:spcAft>
+              <a:defRPr sz="1100" b="0">
                 <a:solidFill>
                   <a:srgbClr val="212529"/>
                 </a:solidFill>
@@ -12669,9 +12669,9 @@
           <a:p>
             <a:pPr>
               <a:spcAft>
-                <a:spcPts val="200"/>
-              </a:spcAft>
-              <a:defRPr sz="1000" b="0">
+                <a:spcPts val="250"/>
+              </a:spcAft>
+              <a:defRPr sz="1100" b="0">
                 <a:solidFill>
                   <a:srgbClr val="212529"/>
                 </a:solidFill>
@@ -12685,9 +12685,9 @@
           <a:p>
             <a:pPr>
               <a:spcAft>
-                <a:spcPts val="200"/>
-              </a:spcAft>
-              <a:defRPr sz="1000" b="0">
+                <a:spcPts val="250"/>
+              </a:spcAft>
+              <a:defRPr sz="1100" b="0">
                 <a:solidFill>
                   <a:srgbClr val="212529"/>
                 </a:solidFill>
@@ -12701,9 +12701,9 @@
           <a:p>
             <a:pPr>
               <a:spcAft>
-                <a:spcPts val="200"/>
-              </a:spcAft>
-              <a:defRPr sz="1000" b="0">
+                <a:spcPts val="250"/>
+              </a:spcAft>
+              <a:defRPr sz="1100" b="0">
                 <a:solidFill>
                   <a:srgbClr val="212529"/>
                 </a:solidFill>
@@ -12761,7 +12761,7 @@
               <a:spcAft>
                 <a:spcPts val="600"/>
               </a:spcAft>
-              <a:defRPr sz="1200" b="1">
+              <a:defRPr sz="1300" b="1">
                 <a:solidFill>
                   <a:srgbClr val="102C57"/>
                 </a:solidFill>
@@ -12775,9 +12775,9 @@
           <a:p>
             <a:pPr>
               <a:spcAft>
-                <a:spcPts val="200"/>
-              </a:spcAft>
-              <a:defRPr sz="1000" b="1">
+                <a:spcPts val="250"/>
+              </a:spcAft>
+              <a:defRPr sz="1100" b="1">
                 <a:solidFill>
                   <a:srgbClr val="102C57"/>
                 </a:solidFill>
@@ -12791,9 +12791,9 @@
           <a:p>
             <a:pPr>
               <a:spcAft>
-                <a:spcPts val="200"/>
-              </a:spcAft>
-              <a:defRPr sz="1000" b="0">
+                <a:spcPts val="250"/>
+              </a:spcAft>
+              <a:defRPr sz="1100" b="0">
                 <a:solidFill>
                   <a:srgbClr val="212529"/>
                 </a:solidFill>
@@ -12807,9 +12807,9 @@
           <a:p>
             <a:pPr>
               <a:spcAft>
-                <a:spcPts val="200"/>
-              </a:spcAft>
-              <a:defRPr sz="1000" b="0">
+                <a:spcPts val="250"/>
+              </a:spcAft>
+              <a:defRPr sz="1100" b="0">
                 <a:solidFill>
                   <a:srgbClr val="212529"/>
                 </a:solidFill>
@@ -12823,9 +12823,9 @@
           <a:p>
             <a:pPr>
               <a:spcAft>
-                <a:spcPts val="200"/>
-              </a:spcAft>
-              <a:defRPr sz="1000" b="0">
+                <a:spcPts val="250"/>
+              </a:spcAft>
+              <a:defRPr sz="1100" b="0">
                 <a:solidFill>
                   <a:srgbClr val="212529"/>
                 </a:solidFill>
@@ -12836,9 +12836,9 @@
           <a:p>
             <a:pPr>
               <a:spcAft>
-                <a:spcPts val="200"/>
-              </a:spcAft>
-              <a:defRPr sz="1000" b="1">
+                <a:spcPts val="250"/>
+              </a:spcAft>
+              <a:defRPr sz="1100" b="1">
                 <a:solidFill>
                   <a:srgbClr val="102C57"/>
                 </a:solidFill>
@@ -12852,9 +12852,9 @@
           <a:p>
             <a:pPr>
               <a:spcAft>
-                <a:spcPts val="200"/>
-              </a:spcAft>
-              <a:defRPr sz="1000" b="0">
+                <a:spcPts val="250"/>
+              </a:spcAft>
+              <a:defRPr sz="1100" b="0">
                 <a:solidFill>
                   <a:srgbClr val="212529"/>
                 </a:solidFill>
@@ -12868,9 +12868,9 @@
           <a:p>
             <a:pPr>
               <a:spcAft>
-                <a:spcPts val="200"/>
-              </a:spcAft>
-              <a:defRPr sz="1000" b="0">
+                <a:spcPts val="250"/>
+              </a:spcAft>
+              <a:defRPr sz="1100" b="0">
                 <a:solidFill>
                   <a:srgbClr val="212529"/>
                 </a:solidFill>
@@ -12884,9 +12884,9 @@
           <a:p>
             <a:pPr>
               <a:spcAft>
-                <a:spcPts val="200"/>
-              </a:spcAft>
-              <a:defRPr sz="1000" b="0">
+                <a:spcPts val="250"/>
+              </a:spcAft>
+              <a:defRPr sz="1100" b="0">
                 <a:solidFill>
                   <a:srgbClr val="212529"/>
                 </a:solidFill>
@@ -12900,9 +12900,9 @@
           <a:p>
             <a:pPr>
               <a:spcAft>
-                <a:spcPts val="200"/>
-              </a:spcAft>
-              <a:defRPr sz="1000" b="0">
+                <a:spcPts val="250"/>
+              </a:spcAft>
+              <a:defRPr sz="1100" b="0">
                 <a:solidFill>
                   <a:srgbClr val="212529"/>
                 </a:solidFill>
@@ -12916,9 +12916,9 @@
           <a:p>
             <a:pPr>
               <a:spcAft>
-                <a:spcPts val="200"/>
-              </a:spcAft>
-              <a:defRPr sz="1000" b="0">
+                <a:spcPts val="250"/>
+              </a:spcAft>
+              <a:defRPr sz="1100" b="0">
                 <a:solidFill>
                   <a:srgbClr val="212529"/>
                 </a:solidFill>
@@ -12932,9 +12932,9 @@
           <a:p>
             <a:pPr>
               <a:spcAft>
-                <a:spcPts val="200"/>
-              </a:spcAft>
-              <a:defRPr sz="1000" b="0">
+                <a:spcPts val="250"/>
+              </a:spcAft>
+              <a:defRPr sz="1100" b="0">
                 <a:solidFill>
                   <a:srgbClr val="212529"/>
                 </a:solidFill>
@@ -12992,7 +12992,7 @@
               <a:spcAft>
                 <a:spcPts val="600"/>
               </a:spcAft>
-              <a:defRPr sz="1200" b="1">
+              <a:defRPr sz="1300" b="1">
                 <a:solidFill>
                   <a:srgbClr val="102C57"/>
                 </a:solidFill>
@@ -13006,9 +13006,9 @@
           <a:p>
             <a:pPr>
               <a:spcAft>
-                <a:spcPts val="200"/>
-              </a:spcAft>
-              <a:defRPr sz="1000" b="1">
+                <a:spcPts val="250"/>
+              </a:spcAft>
+              <a:defRPr sz="1100" b="1">
                 <a:solidFill>
                   <a:srgbClr val="102C57"/>
                 </a:solidFill>
@@ -13022,9 +13022,9 @@
           <a:p>
             <a:pPr>
               <a:spcAft>
-                <a:spcPts val="200"/>
-              </a:spcAft>
-              <a:defRPr sz="1000" b="0">
+                <a:spcPts val="250"/>
+              </a:spcAft>
+              <a:defRPr sz="1100" b="0">
                 <a:solidFill>
                   <a:srgbClr val="212529"/>
                 </a:solidFill>
@@ -13038,9 +13038,9 @@
           <a:p>
             <a:pPr>
               <a:spcAft>
-                <a:spcPts val="200"/>
-              </a:spcAft>
-              <a:defRPr sz="1000" b="0">
+                <a:spcPts val="250"/>
+              </a:spcAft>
+              <a:defRPr sz="1100" b="0">
                 <a:solidFill>
                   <a:srgbClr val="212529"/>
                 </a:solidFill>
@@ -13054,9 +13054,9 @@
           <a:p>
             <a:pPr>
               <a:spcAft>
-                <a:spcPts val="200"/>
-              </a:spcAft>
-              <a:defRPr sz="1000" b="0">
+                <a:spcPts val="250"/>
+              </a:spcAft>
+              <a:defRPr sz="1100" b="0">
                 <a:solidFill>
                   <a:srgbClr val="212529"/>
                 </a:solidFill>
@@ -13070,9 +13070,9 @@
           <a:p>
             <a:pPr>
               <a:spcAft>
-                <a:spcPts val="200"/>
-              </a:spcAft>
-              <a:defRPr sz="1000" b="0">
+                <a:spcPts val="250"/>
+              </a:spcAft>
+              <a:defRPr sz="1100" b="0">
                 <a:solidFill>
                   <a:srgbClr val="212529"/>
                 </a:solidFill>
@@ -13083,9 +13083,9 @@
           <a:p>
             <a:pPr>
               <a:spcAft>
-                <a:spcPts val="200"/>
-              </a:spcAft>
-              <a:defRPr sz="1000" b="1">
+                <a:spcPts val="250"/>
+              </a:spcAft>
+              <a:defRPr sz="1100" b="1">
                 <a:solidFill>
                   <a:srgbClr val="102C57"/>
                 </a:solidFill>
@@ -13099,9 +13099,9 @@
           <a:p>
             <a:pPr>
               <a:spcAft>
-                <a:spcPts val="200"/>
-              </a:spcAft>
-              <a:defRPr sz="1000" b="0">
+                <a:spcPts val="250"/>
+              </a:spcAft>
+              <a:defRPr sz="1100" b="0">
                 <a:solidFill>
                   <a:srgbClr val="212529"/>
                 </a:solidFill>
@@ -13115,9 +13115,9 @@
           <a:p>
             <a:pPr>
               <a:spcAft>
-                <a:spcPts val="200"/>
-              </a:spcAft>
-              <a:defRPr sz="1000" b="0">
+                <a:spcPts val="250"/>
+              </a:spcAft>
+              <a:defRPr sz="1100" b="0">
                 <a:solidFill>
                   <a:srgbClr val="212529"/>
                 </a:solidFill>
@@ -13128,9 +13128,9 @@
           <a:p>
             <a:pPr>
               <a:spcAft>
-                <a:spcPts val="200"/>
-              </a:spcAft>
-              <a:defRPr sz="1000" b="1">
+                <a:spcPts val="250"/>
+              </a:spcAft>
+              <a:defRPr sz="1100" b="1">
                 <a:solidFill>
                   <a:srgbClr val="102C57"/>
                 </a:solidFill>
@@ -13144,9 +13144,9 @@
           <a:p>
             <a:pPr>
               <a:spcAft>
-                <a:spcPts val="200"/>
-              </a:spcAft>
-              <a:defRPr sz="1000" b="0">
+                <a:spcPts val="250"/>
+              </a:spcAft>
+              <a:defRPr sz="1100" b="0">
                 <a:solidFill>
                   <a:srgbClr val="212529"/>
                 </a:solidFill>
@@ -13160,9 +13160,9 @@
           <a:p>
             <a:pPr>
               <a:spcAft>
-                <a:spcPts val="200"/>
-              </a:spcAft>
-              <a:defRPr sz="1000" b="0">
+                <a:spcPts val="250"/>
+              </a:spcAft>
+              <a:defRPr sz="1100" b="0">
                 <a:solidFill>
                   <a:srgbClr val="212529"/>
                 </a:solidFill>
@@ -13173,9 +13173,9 @@
           <a:p>
             <a:pPr>
               <a:spcAft>
-                <a:spcPts val="200"/>
-              </a:spcAft>
-              <a:defRPr sz="1000" b="0">
+                <a:spcPts val="250"/>
+              </a:spcAft>
+              <a:defRPr sz="1100" b="0">
                 <a:solidFill>
                   <a:srgbClr val="212529"/>
                 </a:solidFill>
@@ -13215,7 +13215,7 @@
         <p:spPr>
           <a:xfrm>
             <a:off x="731520" y="365760"/>
-            <a:ext cx="10515600" cy="822960"/>
+            <a:ext cx="10789920" cy="822960"/>
           </a:xfrm>
           <a:prstGeom prst="rect">
             <a:avLst/>
@@ -13229,7 +13229,7 @@
           <a:lstStyle/>
           <a:p>
             <a:pPr>
-              <a:defRPr sz="2400" b="1">
+              <a:defRPr sz="2600" b="1">
                 <a:solidFill>
                   <a:srgbClr val="102C57"/>
                 </a:solidFill>
@@ -13237,7 +13237,7 @@
               </a:defRPr>
             </a:pPr>
             <a:r>
-              <a:t>System Modules Breakdown (Rubric: 2 Marks)</a:t>
+              <a:t>System Modules Breakdown</a:t>
             </a:r>
           </a:p>
         </p:txBody>
@@ -13251,7 +13251,7 @@
         <p:spPr>
           <a:xfrm>
             <a:off x="731520" y="1188720"/>
-            <a:ext cx="10515600" cy="5120640"/>
+            <a:ext cx="10789920" cy="5120640"/>
           </a:xfrm>
           <a:prstGeom prst="rect">
             <a:avLst/>
@@ -13266,11 +13266,11 @@
           <a:p>
             <a:pPr>
               <a:spcAft>
-                <a:spcPts val="600"/>
+                <a:spcPts val="700"/>
               </a:spcAft>
             </a:pPr>
             <a:r>
-              <a:rPr b="1" sz="1100">
+              <a:rPr b="1" sz="1250">
                 <a:solidFill>
                   <a:srgbClr val="102C57"/>
                 </a:solidFill>
@@ -13278,7 +13278,7 @@
               <a:t>Module 1 -- Article Ingestion &amp; Web Scraper: </a:t>
             </a:r>
             <a:r>
-              <a:rPr sz="1100">
+              <a:rPr sz="1250">
                 <a:solidFill>
                   <a:srgbClr val="212529"/>
                 </a:solidFill>
@@ -13289,11 +13289,11 @@
           <a:p>
             <a:pPr>
               <a:spcAft>
-                <a:spcPts val="600"/>
+                <a:spcPts val="700"/>
               </a:spcAft>
             </a:pPr>
             <a:r>
-              <a:rPr b="1" sz="1100">
+              <a:rPr b="1" sz="1250">
                 <a:solidFill>
                   <a:srgbClr val="102C57"/>
                 </a:solidFill>
@@ -13301,7 +13301,7 @@
               <a:t>Module 2 -- Factual Claim Extractor: </a:t>
             </a:r>
             <a:r>
-              <a:rPr sz="1100">
+              <a:rPr sz="1250">
                 <a:solidFill>
                   <a:srgbClr val="212529"/>
                 </a:solidFill>
@@ -13312,11 +13312,11 @@
           <a:p>
             <a:pPr>
               <a:spcAft>
-                <a:spcPts val="600"/>
+                <a:spcPts val="700"/>
               </a:spcAft>
             </a:pPr>
             <a:r>
-              <a:rPr b="1" sz="1100">
+              <a:rPr b="1" sz="1250">
                 <a:solidFill>
                   <a:srgbClr val="102C57"/>
                 </a:solidFill>
@@ -13324,7 +13324,7 @@
               <a:t>Module 3 -- Evidence Retrieval Engine: </a:t>
             </a:r>
             <a:r>
-              <a:rPr sz="1100">
+              <a:rPr sz="1250">
                 <a:solidFill>
                   <a:srgbClr val="212529"/>
                 </a:solidFill>
@@ -13335,11 +13335,11 @@
           <a:p>
             <a:pPr>
               <a:spcAft>
-                <a:spcPts val="600"/>
+                <a:spcPts val="700"/>
               </a:spcAft>
             </a:pPr>
             <a:r>
-              <a:rPr b="1" sz="1100">
+              <a:rPr b="1" sz="1250">
                 <a:solidFill>
                   <a:srgbClr val="102C57"/>
                 </a:solidFill>
@@ -13347,7 +13347,7 @@
               <a:t>Module 4 -- MBFC Source Reputation Database: </a:t>
             </a:r>
             <a:r>
-              <a:rPr sz="1100">
+              <a:rPr sz="1250">
                 <a:solidFill>
                   <a:srgbClr val="212529"/>
                 </a:solidFill>
@@ -13358,11 +13358,11 @@
           <a:p>
             <a:pPr>
               <a:spcAft>
-                <a:spcPts val="600"/>
+                <a:spcPts val="700"/>
               </a:spcAft>
             </a:pPr>
             <a:r>
-              <a:rPr b="1" sz="1100">
+              <a:rPr b="1" sz="1250">
                 <a:solidFill>
                   <a:srgbClr val="102C57"/>
                 </a:solidFill>
@@ -13370,7 +13370,7 @@
               <a:t>Module 5 -- RoBERTa-MNLI &amp; Manipulation Engine: </a:t>
             </a:r>
             <a:r>
-              <a:rPr sz="1100">
+              <a:rPr sz="1250">
                 <a:solidFill>
                   <a:srgbClr val="212529"/>
                 </a:solidFill>
@@ -13381,11 +13381,11 @@
           <a:p>
             <a:pPr>
               <a:spcAft>
-                <a:spcPts val="600"/>
+                <a:spcPts val="700"/>
               </a:spcAft>
             </a:pPr>
             <a:r>
-              <a:rPr b="1" sz="1100">
+              <a:rPr b="1" sz="1250">
                 <a:solidFill>
                   <a:srgbClr val="102C57"/>
                 </a:solidFill>
@@ -13393,7 +13393,7 @@
               <a:t>Module 6 -- Score Aggregation &amp; Visual Dashboard: </a:t>
             </a:r>
             <a:r>
-              <a:rPr sz="1100">
+              <a:rPr sz="1250">
                 <a:solidFill>
                   <a:srgbClr val="212529"/>
                 </a:solidFill>
@@ -13430,7 +13430,7 @@
         <p:spPr>
           <a:xfrm>
             <a:off x="731520" y="365760"/>
-            <a:ext cx="10515600" cy="822960"/>
+            <a:ext cx="10789920" cy="822960"/>
           </a:xfrm>
           <a:prstGeom prst="rect">
             <a:avLst/>
@@ -13444,7 +13444,7 @@
           <a:lstStyle/>
           <a:p>
             <a:pPr>
-              <a:defRPr sz="2400" b="1">
+              <a:defRPr sz="2600" b="1">
                 <a:solidFill>
                   <a:srgbClr val="102C57"/>
                 </a:solidFill>
@@ -13452,7 +13452,7 @@
               </a:defRPr>
             </a:pPr>
             <a:r>
-              <a:t>Hardware and Software Details (Rubric: 1 Mark)</a:t>
+              <a:t>Hardware and Software Details</a:t>
             </a:r>
           </a:p>
         </p:txBody>
@@ -13467,7 +13467,7 @@
         </p:nvGraphicFramePr>
         <p:xfrm>
           <a:off x="731520" y="1188720"/>
-          <a:ext cx="10515600" cy="5120640"/>
+          <a:ext cx="10789920" cy="5120640"/>
         </p:xfrm>
         <a:graphic>
           <a:graphicData uri="http://schemas.openxmlformats.org/drawingml/2006/table">
@@ -13477,8 +13477,8 @@
               </a:tblPr>
               <a:tblGrid>
                 <a:gridCol w="2286000"/>
-                <a:gridCol w="3840480"/>
-                <a:gridCol w="4389120"/>
+                <a:gridCol w="3931920"/>
+                <a:gridCol w="4572000"/>
               </a:tblGrid>
               <a:tr h="465512">
                 <a:tc>
@@ -13487,7 +13487,7 @@
                     <a:lstStyle/>
                     <a:p>
                       <a:pPr algn="l">
-                        <a:defRPr sz="950" b="1">
+                        <a:defRPr sz="1100" b="1">
                           <a:solidFill>
                             <a:srgbClr val="FFFFFF"/>
                           </a:solidFill>
@@ -13511,7 +13511,7 @@
                     <a:lstStyle/>
                     <a:p>
                       <a:pPr algn="l">
-                        <a:defRPr sz="950" b="1">
+                        <a:defRPr sz="1100" b="1">
                           <a:solidFill>
                             <a:srgbClr val="FFFFFF"/>
                           </a:solidFill>
@@ -13535,7 +13535,7 @@
                     <a:lstStyle/>
                     <a:p>
                       <a:pPr algn="l">
-                        <a:defRPr sz="950" b="1">
+                        <a:defRPr sz="1100" b="1">
                           <a:solidFill>
                             <a:srgbClr val="FFFFFF"/>
                           </a:solidFill>
@@ -13561,7 +13561,7 @@
                     <a:lstStyle/>
                     <a:p>
                       <a:pPr algn="l">
-                        <a:defRPr sz="850" b="0">
+                        <a:defRPr sz="950" b="0">
                           <a:solidFill>
                             <a:srgbClr val="212529"/>
                           </a:solidFill>
@@ -13585,7 +13585,7 @@
                     <a:lstStyle/>
                     <a:p>
                       <a:pPr algn="l">
-                        <a:defRPr sz="850" b="0">
+                        <a:defRPr sz="950" b="0">
                           <a:solidFill>
                             <a:srgbClr val="212529"/>
                           </a:solidFill>
@@ -13609,7 +13609,7 @@
                     <a:lstStyle/>
                     <a:p>
                       <a:pPr algn="l">
-                        <a:defRPr sz="850" b="0">
+                        <a:defRPr sz="950" b="0">
                           <a:solidFill>
                             <a:srgbClr val="212529"/>
                           </a:solidFill>
@@ -13635,7 +13635,7 @@
                     <a:lstStyle/>
                     <a:p>
                       <a:pPr algn="l">
-                        <a:defRPr sz="850" b="0">
+                        <a:defRPr sz="950" b="0">
                           <a:solidFill>
                             <a:srgbClr val="212529"/>
                           </a:solidFill>
@@ -13655,7 +13655,7 @@
                     <a:lstStyle/>
                     <a:p>
                       <a:pPr algn="l">
-                        <a:defRPr sz="850" b="0">
+                        <a:defRPr sz="950" b="0">
                           <a:solidFill>
                             <a:srgbClr val="212529"/>
                           </a:solidFill>
@@ -13675,7 +13675,7 @@
                     <a:lstStyle/>
                     <a:p>
                       <a:pPr algn="l">
-                        <a:defRPr sz="850" b="0">
+                        <a:defRPr sz="950" b="0">
                           <a:solidFill>
                             <a:srgbClr val="212529"/>
                           </a:solidFill>
@@ -13697,7 +13697,7 @@
                     <a:lstStyle/>
                     <a:p>
                       <a:pPr algn="l">
-                        <a:defRPr sz="850" b="0">
+                        <a:defRPr sz="950" b="0">
                           <a:solidFill>
                             <a:srgbClr val="212529"/>
                           </a:solidFill>
@@ -13721,7 +13721,7 @@
                     <a:lstStyle/>
                     <a:p>
                       <a:pPr algn="l">
-                        <a:defRPr sz="850" b="0">
+                        <a:defRPr sz="950" b="0">
                           <a:solidFill>
                             <a:srgbClr val="212529"/>
                           </a:solidFill>
@@ -13745,7 +13745,7 @@
                     <a:lstStyle/>
                     <a:p>
                       <a:pPr algn="l">
-                        <a:defRPr sz="850" b="0">
+                        <a:defRPr sz="950" b="0">
                           <a:solidFill>
                             <a:srgbClr val="212529"/>
                           </a:solidFill>
@@ -13771,7 +13771,7 @@
                     <a:lstStyle/>
                     <a:p>
                       <a:pPr algn="l">
-                        <a:defRPr sz="850" b="0">
+                        <a:defRPr sz="950" b="0">
                           <a:solidFill>
                             <a:srgbClr val="212529"/>
                           </a:solidFill>
@@ -13791,7 +13791,7 @@
                     <a:lstStyle/>
                     <a:p>
                       <a:pPr algn="l">
-                        <a:defRPr sz="850" b="0">
+                        <a:defRPr sz="950" b="0">
                           <a:solidFill>
                             <a:srgbClr val="212529"/>
                           </a:solidFill>
@@ -13811,7 +13811,7 @@
                     <a:lstStyle/>
                     <a:p>
                       <a:pPr algn="l">
-                        <a:defRPr sz="850" b="0">
+                        <a:defRPr sz="950" b="0">
                           <a:solidFill>
                             <a:srgbClr val="212529"/>
                           </a:solidFill>
@@ -13833,7 +13833,7 @@
                     <a:lstStyle/>
                     <a:p>
                       <a:pPr algn="l">
-                        <a:defRPr sz="850" b="0">
+                        <a:defRPr sz="950" b="0">
                           <a:solidFill>
                             <a:srgbClr val="212529"/>
                           </a:solidFill>
@@ -13857,7 +13857,7 @@
                     <a:lstStyle/>
                     <a:p>
                       <a:pPr algn="l">
-                        <a:defRPr sz="850" b="0">
+                        <a:defRPr sz="950" b="0">
                           <a:solidFill>
                             <a:srgbClr val="212529"/>
                           </a:solidFill>
@@ -13881,7 +13881,7 @@
                     <a:lstStyle/>
                     <a:p>
                       <a:pPr algn="l">
-                        <a:defRPr sz="850" b="0">
+                        <a:defRPr sz="950" b="0">
                           <a:solidFill>
                             <a:srgbClr val="212529"/>
                           </a:solidFill>
@@ -13907,7 +13907,7 @@
                     <a:lstStyle/>
                     <a:p>
                       <a:pPr algn="l">
-                        <a:defRPr sz="850" b="0">
+                        <a:defRPr sz="950" b="0">
                           <a:solidFill>
                             <a:srgbClr val="212529"/>
                           </a:solidFill>
@@ -13927,7 +13927,7 @@
                     <a:lstStyle/>
                     <a:p>
                       <a:pPr algn="l">
-                        <a:defRPr sz="850" b="0">
+                        <a:defRPr sz="950" b="0">
                           <a:solidFill>
                             <a:srgbClr val="212529"/>
                           </a:solidFill>
@@ -13947,7 +13947,7 @@
                     <a:lstStyle/>
                     <a:p>
                       <a:pPr algn="l">
-                        <a:defRPr sz="850" b="0">
+                        <a:defRPr sz="950" b="0">
                           <a:solidFill>
                             <a:srgbClr val="212529"/>
                           </a:solidFill>
@@ -13969,7 +13969,7 @@
                     <a:lstStyle/>
                     <a:p>
                       <a:pPr algn="l">
-                        <a:defRPr sz="850" b="0">
+                        <a:defRPr sz="950" b="0">
                           <a:solidFill>
                             <a:srgbClr val="212529"/>
                           </a:solidFill>
@@ -13993,7 +13993,7 @@
                     <a:lstStyle/>
                     <a:p>
                       <a:pPr algn="l">
-                        <a:defRPr sz="850" b="0">
+                        <a:defRPr sz="950" b="0">
                           <a:solidFill>
                             <a:srgbClr val="212529"/>
                           </a:solidFill>
@@ -14017,7 +14017,7 @@
                     <a:lstStyle/>
                     <a:p>
                       <a:pPr algn="l">
-                        <a:defRPr sz="850" b="0">
+                        <a:defRPr sz="950" b="0">
                           <a:solidFill>
                             <a:srgbClr val="212529"/>
                           </a:solidFill>
@@ -14043,7 +14043,7 @@
                     <a:lstStyle/>
                     <a:p>
                       <a:pPr algn="l">
-                        <a:defRPr sz="850" b="0">
+                        <a:defRPr sz="950" b="0">
                           <a:solidFill>
                             <a:srgbClr val="212529"/>
                           </a:solidFill>
@@ -14063,7 +14063,7 @@
                     <a:lstStyle/>
                     <a:p>
                       <a:pPr algn="l">
-                        <a:defRPr sz="850" b="0">
+                        <a:defRPr sz="950" b="0">
                           <a:solidFill>
                             <a:srgbClr val="212529"/>
                           </a:solidFill>
@@ -14083,7 +14083,7 @@
                     <a:lstStyle/>
                     <a:p>
                       <a:pPr algn="l">
-                        <a:defRPr sz="850" b="0">
+                        <a:defRPr sz="950" b="0">
                           <a:solidFill>
                             <a:srgbClr val="212529"/>
                           </a:solidFill>
@@ -14105,7 +14105,7 @@
                     <a:lstStyle/>
                     <a:p>
                       <a:pPr algn="l">
-                        <a:defRPr sz="850" b="0">
+                        <a:defRPr sz="950" b="0">
                           <a:solidFill>
                             <a:srgbClr val="212529"/>
                           </a:solidFill>
@@ -14129,7 +14129,7 @@
                     <a:lstStyle/>
                     <a:p>
                       <a:pPr algn="l">
-                        <a:defRPr sz="850" b="0">
+                        <a:defRPr sz="950" b="0">
                           <a:solidFill>
                             <a:srgbClr val="212529"/>
                           </a:solidFill>
@@ -14153,7 +14153,7 @@
                     <a:lstStyle/>
                     <a:p>
                       <a:pPr algn="l">
-                        <a:defRPr sz="850" b="0">
+                        <a:defRPr sz="950" b="0">
                           <a:solidFill>
                             <a:srgbClr val="212529"/>
                           </a:solidFill>
@@ -14179,7 +14179,7 @@
                     <a:lstStyle/>
                     <a:p>
                       <a:pPr algn="l">
-                        <a:defRPr sz="850" b="0">
+                        <a:defRPr sz="950" b="0">
                           <a:solidFill>
                             <a:srgbClr val="212529"/>
                           </a:solidFill>
@@ -14199,7 +14199,7 @@
                     <a:lstStyle/>
                     <a:p>
                       <a:pPr algn="l">
-                        <a:defRPr sz="850" b="0">
+                        <a:defRPr sz="950" b="0">
                           <a:solidFill>
                             <a:srgbClr val="212529"/>
                           </a:solidFill>
@@ -14224,7 +14224,7 @@
                     <a:lstStyle/>
                     <a:p>
                       <a:pPr algn="l">
-                        <a:defRPr sz="850" b="0">
+                        <a:defRPr sz="950" b="0">
                           <a:solidFill>
                             <a:srgbClr val="212529"/>
                           </a:solidFill>
@@ -14270,7 +14270,7 @@
         <p:spPr>
           <a:xfrm>
             <a:off x="731520" y="365760"/>
-            <a:ext cx="10515600" cy="822960"/>
+            <a:ext cx="10789920" cy="822960"/>
           </a:xfrm>
           <a:prstGeom prst="rect">
             <a:avLst/>
@@ -14284,7 +14284,7 @@
           <a:lstStyle/>
           <a:p>
             <a:pPr>
-              <a:defRPr sz="2400" b="1">
+              <a:defRPr sz="2600" b="1">
                 <a:solidFill>
                   <a:srgbClr val="102C57"/>
                 </a:solidFill>
@@ -14292,7 +14292,7 @@
               </a:defRPr>
             </a:pPr>
             <a:r>
-              <a:t>Timeline of the Project -- 5-Phase Plan (Rubric: 1 Mark)</a:t>
+              <a:t>Timeline of the Project -- 5-Phase Plan</a:t>
             </a:r>
           </a:p>
         </p:txBody>
@@ -14307,7 +14307,7 @@
         </p:nvGraphicFramePr>
         <p:xfrm>
           <a:off x="731520" y="1280160"/>
-          <a:ext cx="10515600" cy="4754880"/>
+          <a:ext cx="10789920" cy="4754880"/>
         </p:xfrm>
         <a:graphic>
           <a:graphicData uri="http://schemas.openxmlformats.org/drawingml/2006/table">
@@ -14318,7 +14318,7 @@
               <a:tblGrid>
                 <a:gridCol w="1280160"/>
                 <a:gridCol w="1463040"/>
-                <a:gridCol w="5943600"/>
+                <a:gridCol w="6217920"/>
                 <a:gridCol w="1828800"/>
               </a:tblGrid>
               <a:tr h="792480">
@@ -14328,7 +14328,7 @@
                     <a:lstStyle/>
                     <a:p>
                       <a:pPr algn="l">
-                        <a:defRPr sz="1100" b="1">
+                        <a:defRPr sz="1200" b="1">
                           <a:solidFill>
                             <a:srgbClr val="FFFFFF"/>
                           </a:solidFill>
@@ -14352,7 +14352,7 @@
                     <a:lstStyle/>
                     <a:p>
                       <a:pPr algn="l">
-                        <a:defRPr sz="1100" b="1">
+                        <a:defRPr sz="1200" b="1">
                           <a:solidFill>
                             <a:srgbClr val="FFFFFF"/>
                           </a:solidFill>
@@ -14376,7 +14376,7 @@
                     <a:lstStyle/>
                     <a:p>
                       <a:pPr algn="l">
-                        <a:defRPr sz="1100" b="1">
+                        <a:defRPr sz="1200" b="1">
                           <a:solidFill>
                             <a:srgbClr val="FFFFFF"/>
                           </a:solidFill>
@@ -14400,7 +14400,7 @@
                     <a:lstStyle/>
                     <a:p>
                       <a:pPr algn="l">
-                        <a:defRPr sz="1100" b="1">
+                        <a:defRPr sz="1200" b="1">
                           <a:solidFill>
                             <a:srgbClr val="FFFFFF"/>
                           </a:solidFill>
@@ -14426,7 +14426,7 @@
                     <a:lstStyle/>
                     <a:p>
                       <a:pPr algn="l">
-                        <a:defRPr sz="1000" b="0">
+                        <a:defRPr sz="1100" b="0">
                           <a:solidFill>
                             <a:srgbClr val="212529"/>
                           </a:solidFill>
@@ -14450,7 +14450,7 @@
                     <a:lstStyle/>
                     <a:p>
                       <a:pPr algn="l">
-                        <a:defRPr sz="1000" b="0">
+                        <a:defRPr sz="1100" b="0">
                           <a:solidFill>
                             <a:srgbClr val="212529"/>
                           </a:solidFill>
@@ -14474,7 +14474,7 @@
                     <a:lstStyle/>
                     <a:p>
                       <a:pPr algn="l">
-                        <a:defRPr sz="1000" b="0">
+                        <a:defRPr sz="1100" b="0">
                           <a:solidFill>
                             <a:srgbClr val="212529"/>
                           </a:solidFill>
@@ -14498,7 +14498,7 @@
                     <a:lstStyle/>
                     <a:p>
                       <a:pPr algn="l">
-                        <a:defRPr sz="1000" b="0">
+                        <a:defRPr sz="1100" b="0">
                           <a:solidFill>
                             <a:srgbClr val="212529"/>
                           </a:solidFill>
@@ -14524,7 +14524,7 @@
                     <a:lstStyle/>
                     <a:p>
                       <a:pPr algn="l">
-                        <a:defRPr sz="1000" b="0">
+                        <a:defRPr sz="1100" b="0">
                           <a:solidFill>
                             <a:srgbClr val="212529"/>
                           </a:solidFill>
@@ -14544,7 +14544,7 @@
                     <a:lstStyle/>
                     <a:p>
                       <a:pPr algn="l">
-                        <a:defRPr sz="1000" b="0">
+                        <a:defRPr sz="1100" b="0">
                           <a:solidFill>
                             <a:srgbClr val="212529"/>
                           </a:solidFill>
@@ -14564,7 +14564,7 @@
                     <a:lstStyle/>
                     <a:p>
                       <a:pPr algn="l">
-                        <a:defRPr sz="1000" b="0">
+                        <a:defRPr sz="1100" b="0">
                           <a:solidFill>
                             <a:srgbClr val="212529"/>
                           </a:solidFill>
@@ -14584,7 +14584,7 @@
                     <a:lstStyle/>
                     <a:p>
                       <a:pPr algn="l">
-                        <a:defRPr sz="1000" b="0">
+                        <a:defRPr sz="1100" b="0">
                           <a:solidFill>
                             <a:srgbClr val="212529"/>
                           </a:solidFill>
@@ -14606,7 +14606,7 @@
                     <a:lstStyle/>
                     <a:p>
                       <a:pPr algn="l">
-                        <a:defRPr sz="1000" b="0">
+                        <a:defRPr sz="1100" b="0">
                           <a:solidFill>
                             <a:srgbClr val="212529"/>
                           </a:solidFill>
@@ -14630,7 +14630,7 @@
                     <a:lstStyle/>
                     <a:p>
                       <a:pPr algn="l">
-                        <a:defRPr sz="1000" b="0">
+                        <a:defRPr sz="1100" b="0">
                           <a:solidFill>
                             <a:srgbClr val="212529"/>
                           </a:solidFill>
@@ -14654,7 +14654,7 @@
                     <a:lstStyle/>
                     <a:p>
                       <a:pPr algn="l">
-                        <a:defRPr sz="1000" b="0">
+                        <a:defRPr sz="1100" b="0">
                           <a:solidFill>
                             <a:srgbClr val="212529"/>
                           </a:solidFill>
@@ -14678,7 +14678,7 @@
                     <a:lstStyle/>
                     <a:p>
                       <a:pPr algn="l">
-                        <a:defRPr sz="1000" b="0">
+                        <a:defRPr sz="1100" b="0">
                           <a:solidFill>
                             <a:srgbClr val="212529"/>
                           </a:solidFill>
@@ -14704,7 +14704,7 @@
                     <a:lstStyle/>
                     <a:p>
                       <a:pPr algn="l">
-                        <a:defRPr sz="1000" b="0">
+                        <a:defRPr sz="1100" b="0">
                           <a:solidFill>
                             <a:srgbClr val="212529"/>
                           </a:solidFill>
@@ -14724,7 +14724,7 @@
                     <a:lstStyle/>
                     <a:p>
                       <a:pPr algn="l">
-                        <a:defRPr sz="1000" b="0">
+                        <a:defRPr sz="1100" b="0">
                           <a:solidFill>
                             <a:srgbClr val="212529"/>
                           </a:solidFill>
@@ -14744,7 +14744,7 @@
                     <a:lstStyle/>
                     <a:p>
                       <a:pPr algn="l">
-                        <a:defRPr sz="1000" b="0">
+                        <a:defRPr sz="1100" b="0">
                           <a:solidFill>
                             <a:srgbClr val="212529"/>
                           </a:solidFill>
@@ -14764,7 +14764,7 @@
                     <a:lstStyle/>
                     <a:p>
                       <a:pPr algn="l">
-                        <a:defRPr sz="1000" b="0">
+                        <a:defRPr sz="1100" b="0">
                           <a:solidFill>
                             <a:srgbClr val="212529"/>
                           </a:solidFill>
@@ -14786,7 +14786,7 @@
                     <a:lstStyle/>
                     <a:p>
                       <a:pPr algn="l">
-                        <a:defRPr sz="1000" b="0">
+                        <a:defRPr sz="1100" b="0">
                           <a:solidFill>
                             <a:srgbClr val="212529"/>
                           </a:solidFill>
@@ -14810,7 +14810,7 @@
                     <a:lstStyle/>
                     <a:p>
                       <a:pPr algn="l">
-                        <a:defRPr sz="1000" b="0">
+                        <a:defRPr sz="1100" b="0">
                           <a:solidFill>
                             <a:srgbClr val="212529"/>
                           </a:solidFill>
@@ -14834,7 +14834,7 @@
                     <a:lstStyle/>
                     <a:p>
                       <a:pPr algn="l">
-                        <a:defRPr sz="1000" b="0">
+                        <a:defRPr sz="1100" b="0">
                           <a:solidFill>
                             <a:srgbClr val="212529"/>
                           </a:solidFill>
@@ -14858,7 +14858,7 @@
                     <a:lstStyle/>
                     <a:p>
                       <a:pPr algn="l">
-                        <a:defRPr sz="1000" b="0">
+                        <a:defRPr sz="1100" b="0">
                           <a:solidFill>
                             <a:srgbClr val="212529"/>
                           </a:solidFill>
@@ -14908,7 +14908,7 @@
         <p:spPr>
           <a:xfrm>
             <a:off x="731520" y="365760"/>
-            <a:ext cx="10515600" cy="822960"/>
+            <a:ext cx="10789920" cy="822960"/>
           </a:xfrm>
           <a:prstGeom prst="rect">
             <a:avLst/>
@@ -14922,7 +14922,7 @@
           <a:lstStyle/>
           <a:p>
             <a:pPr>
-              <a:defRPr sz="2400" b="1">
+              <a:defRPr sz="2600" b="1">
                 <a:solidFill>
                   <a:srgbClr val="102C57"/>
                 </a:solidFill>
@@ -14930,7 +14930,7 @@
               </a:defRPr>
             </a:pPr>
             <a:r>
-              <a:t>References (IEEE Format -- Rubric: 1 Mark)</a:t>
+              <a:t>References (IEEE Format)</a:t>
             </a:r>
           </a:p>
         </p:txBody>
@@ -14944,7 +14944,7 @@
         <p:spPr>
           <a:xfrm>
             <a:off x="731520" y="1188720"/>
-            <a:ext cx="10515600" cy="5120640"/>
+            <a:ext cx="10789920" cy="5120640"/>
           </a:xfrm>
           <a:prstGeom prst="rect">
             <a:avLst/>
@@ -14961,7 +14961,7 @@
               <a:spcAft>
                 <a:spcPts val="250"/>
               </a:spcAft>
-              <a:defRPr sz="850">
+              <a:defRPr sz="950">
                 <a:solidFill>
                   <a:srgbClr val="212529"/>
                 </a:solidFill>
@@ -14977,7 +14977,7 @@
               <a:spcAft>
                 <a:spcPts val="250"/>
               </a:spcAft>
-              <a:defRPr sz="850">
+              <a:defRPr sz="950">
                 <a:solidFill>
                   <a:srgbClr val="212529"/>
                 </a:solidFill>
@@ -14993,7 +14993,7 @@
               <a:spcAft>
                 <a:spcPts val="250"/>
               </a:spcAft>
-              <a:defRPr sz="850">
+              <a:defRPr sz="950">
                 <a:solidFill>
                   <a:srgbClr val="212529"/>
                 </a:solidFill>
@@ -15009,7 +15009,7 @@
               <a:spcAft>
                 <a:spcPts val="250"/>
               </a:spcAft>
-              <a:defRPr sz="850">
+              <a:defRPr sz="950">
                 <a:solidFill>
                   <a:srgbClr val="212529"/>
                 </a:solidFill>
@@ -15025,7 +15025,7 @@
               <a:spcAft>
                 <a:spcPts val="250"/>
               </a:spcAft>
-              <a:defRPr sz="850">
+              <a:defRPr sz="950">
                 <a:solidFill>
                   <a:srgbClr val="212529"/>
                 </a:solidFill>
@@ -15041,7 +15041,7 @@
               <a:spcAft>
                 <a:spcPts val="250"/>
               </a:spcAft>
-              <a:defRPr sz="850">
+              <a:defRPr sz="950">
                 <a:solidFill>
                   <a:srgbClr val="212529"/>
                 </a:solidFill>
@@ -15057,7 +15057,7 @@
               <a:spcAft>
                 <a:spcPts val="250"/>
               </a:spcAft>
-              <a:defRPr sz="850">
+              <a:defRPr sz="950">
                 <a:solidFill>
                   <a:srgbClr val="212529"/>
                 </a:solidFill>
@@ -15073,7 +15073,7 @@
               <a:spcAft>
                 <a:spcPts val="250"/>
               </a:spcAft>
-              <a:defRPr sz="850">
+              <a:defRPr sz="950">
                 <a:solidFill>
                   <a:srgbClr val="212529"/>
                 </a:solidFill>
@@ -15089,7 +15089,7 @@
               <a:spcAft>
                 <a:spcPts val="250"/>
               </a:spcAft>
-              <a:defRPr sz="850">
+              <a:defRPr sz="950">
                 <a:solidFill>
                   <a:srgbClr val="212529"/>
                 </a:solidFill>
@@ -15105,7 +15105,7 @@
               <a:spcAft>
                 <a:spcPts val="250"/>
               </a:spcAft>
-              <a:defRPr sz="850">
+              <a:defRPr sz="950">
                 <a:solidFill>
                   <a:srgbClr val="212529"/>
                 </a:solidFill>
@@ -15121,7 +15121,7 @@
               <a:spcAft>
                 <a:spcPts val="250"/>
               </a:spcAft>
-              <a:defRPr sz="850">
+              <a:defRPr sz="950">
                 <a:solidFill>
                   <a:srgbClr val="212529"/>
                 </a:solidFill>
@@ -15137,7 +15137,7 @@
               <a:spcAft>
                 <a:spcPts val="250"/>
               </a:spcAft>
-              <a:defRPr sz="850">
+              <a:defRPr sz="950">
                 <a:solidFill>
                   <a:srgbClr val="212529"/>
                 </a:solidFill>
@@ -15177,7 +15177,7 @@
         <p:spPr>
           <a:xfrm>
             <a:off x="731520" y="365760"/>
-            <a:ext cx="10515600" cy="822960"/>
+            <a:ext cx="10789920" cy="822960"/>
           </a:xfrm>
           <a:prstGeom prst="rect">
             <a:avLst/>
@@ -15191,7 +15191,7 @@
           <a:lstStyle/>
           <a:p>
             <a:pPr>
-              <a:defRPr sz="2400" b="1">
+              <a:defRPr sz="2600" b="1">
                 <a:solidFill>
                   <a:srgbClr val="102C57"/>
                 </a:solidFill>
@@ -15213,7 +15213,7 @@
         <p:spPr>
           <a:xfrm>
             <a:off x="731520" y="1188720"/>
-            <a:ext cx="10515600" cy="5120640"/>
+            <a:ext cx="10789920" cy="5120640"/>
           </a:xfrm>
           <a:prstGeom prst="rect">
             <a:avLst/>
@@ -15228,9 +15228,9 @@
           <a:p>
             <a:pPr>
               <a:spcAft>
-                <a:spcPts val="600"/>
-              </a:spcAft>
-              <a:defRPr sz="1400" b="1">
+                <a:spcPts val="800"/>
+              </a:spcAft>
+              <a:defRPr sz="1500" b="1">
                 <a:solidFill>
                   <a:srgbClr val="102C57"/>
                 </a:solidFill>
@@ -15244,11 +15244,11 @@
           <a:p>
             <a:pPr>
               <a:spcAft>
-                <a:spcPts val="400"/>
+                <a:spcPts val="500"/>
               </a:spcAft>
             </a:pPr>
             <a:r>
-              <a:rPr b="1" sz="1100">
+              <a:rPr b="1" sz="1250">
                 <a:solidFill>
                   <a:srgbClr val="28A745"/>
                 </a:solidFill>
@@ -15256,7 +15256,7 @@
               <a:t>[+] Source Reputation Database: </a:t>
             </a:r>
             <a:r>
-              <a:rPr sz="1100">
+              <a:rPr sz="1250">
                 <a:solidFill>
                   <a:srgbClr val="212529"/>
                 </a:solidFill>
@@ -15267,11 +15267,11 @@
           <a:p>
             <a:pPr>
               <a:spcAft>
-                <a:spcPts val="400"/>
+                <a:spcPts val="500"/>
               </a:spcAft>
             </a:pPr>
             <a:r>
-              <a:rPr b="1" sz="1100">
+              <a:rPr b="1" sz="1250">
                 <a:solidFill>
                   <a:srgbClr val="28A745"/>
                 </a:solidFill>
@@ -15279,7 +15279,7 @@
               <a:t>[+] Canonical Domain Resolver: </a:t>
             </a:r>
             <a:r>
-              <a:rPr sz="1100">
+              <a:rPr sz="1250">
                 <a:solidFill>
                   <a:srgbClr val="212529"/>
                 </a:solidFill>
@@ -15290,11 +15290,11 @@
           <a:p>
             <a:pPr>
               <a:spcAft>
-                <a:spcPts val="400"/>
+                <a:spcPts val="500"/>
               </a:spcAft>
             </a:pPr>
             <a:r>
-              <a:rPr b="1" sz="1100">
+              <a:rPr b="1" sz="1250">
                 <a:solidFill>
                   <a:srgbClr val="28A745"/>
                 </a:solidFill>
@@ -15302,7 +15302,7 @@
               <a:t>[+] Manipulation Detection Engine: </a:t>
             </a:r>
             <a:r>
-              <a:rPr sz="1100">
+              <a:rPr sz="1250">
                 <a:solidFill>
                   <a:srgbClr val="212529"/>
                 </a:solidFill>
@@ -15313,11 +15313,11 @@
           <a:p>
             <a:pPr>
               <a:spcAft>
-                <a:spcPts val="400"/>
+                <a:spcPts val="500"/>
               </a:spcAft>
             </a:pPr>
             <a:r>
-              <a:rPr b="1" sz="1100">
+              <a:rPr b="1" sz="1250">
                 <a:solidFill>
                   <a:srgbClr val="28A745"/>
                 </a:solidFill>
@@ -15325,7 +15325,7 @@
               <a:t>[+] Ground-Truth Testbed: </a:t>
             </a:r>
             <a:r>
-              <a:rPr sz="1100">
+              <a:rPr sz="1250">
                 <a:solidFill>
                   <a:srgbClr val="212529"/>
                 </a:solidFill>
@@ -15336,11 +15336,11 @@
           <a:p>
             <a:pPr>
               <a:spcAft>
-                <a:spcPts val="400"/>
+                <a:spcPts val="500"/>
               </a:spcAft>
             </a:pPr>
             <a:r>
-              <a:rPr b="1" sz="1100">
+              <a:rPr b="1" sz="1250">
                 <a:solidFill>
                   <a:srgbClr val="28A745"/>
                 </a:solidFill>
@@ -15348,7 +15348,7 @@
               <a:t>[+] Automated Quality Assurance: </a:t>
             </a:r>
             <a:r>
-              <a:rPr sz="1100">
+              <a:rPr sz="1250">
                 <a:solidFill>
                   <a:srgbClr val="212529"/>
                 </a:solidFill>
@@ -15359,11 +15359,11 @@
           <a:p>
             <a:pPr>
               <a:spcAft>
-                <a:spcPts val="400"/>
+                <a:spcPts val="500"/>
               </a:spcAft>
             </a:pPr>
             <a:r>
-              <a:rPr b="1" sz="1100">
+              <a:rPr b="1" sz="1250">
                 <a:solidFill>
                   <a:srgbClr val="28A745"/>
                 </a:solidFill>
@@ -15371,7 +15371,7 @@
               <a:t>[+] GitHub Repository: </a:t>
             </a:r>
             <a:r>
-              <a:rPr sz="1100">
+              <a:rPr sz="1250">
                 <a:solidFill>
                   <a:srgbClr val="212529"/>
                 </a:solidFill>
@@ -16779,7 +16779,7 @@
         <p:spPr>
           <a:xfrm>
             <a:off x="731520" y="365760"/>
-            <a:ext cx="10515600" cy="822960"/>
+            <a:ext cx="10789920" cy="822960"/>
           </a:xfrm>
           <a:prstGeom prst="rect">
             <a:avLst/>
@@ -16793,7 +16793,7 @@
           <a:lstStyle/>
           <a:p>
             <a:pPr>
-              <a:defRPr sz="2400" b="1">
+              <a:defRPr sz="2600" b="1">
                 <a:solidFill>
                   <a:srgbClr val="102C57"/>
                 </a:solidFill>
@@ -16801,7 +16801,7 @@
               </a:defRPr>
             </a:pPr>
             <a:r>
-              <a:t>Table of Contents (Review 2 Evaluation)</a:t>
+              <a:t>Table of Contents</a:t>
             </a:r>
           </a:p>
         </p:txBody>
@@ -16815,7 +16815,7 @@
         <p:spPr>
           <a:xfrm>
             <a:off x="731520" y="1188720"/>
-            <a:ext cx="10515600" cy="5029200"/>
+            <a:ext cx="10789920" cy="5120640"/>
           </a:xfrm>
           <a:prstGeom prst="rect">
             <a:avLst/>
@@ -16830,9 +16830,9 @@
           <a:p>
             <a:pPr>
               <a:spcAft>
-                <a:spcPts val="400"/>
-              </a:spcAft>
-              <a:defRPr sz="1200">
+                <a:spcPts val="350"/>
+              </a:spcAft>
+              <a:defRPr sz="1300">
                 <a:solidFill>
                   <a:srgbClr val="212529"/>
                 </a:solidFill>
@@ -16846,9 +16846,9 @@
           <a:p>
             <a:pPr>
               <a:spcAft>
-                <a:spcPts val="400"/>
-              </a:spcAft>
-              <a:defRPr sz="1200">
+                <a:spcPts val="350"/>
+              </a:spcAft>
+              <a:defRPr sz="1300">
                 <a:solidFill>
                   <a:srgbClr val="212529"/>
                 </a:solidFill>
@@ -16856,15 +16856,15 @@
               </a:defRPr>
             </a:pPr>
             <a:r>
-              <a:t>2. Abstract  --  Problem, Objectives &amp; Approach (Rubric: 2 Marks)</a:t>
+              <a:t>2. Abstract  --  Problem, Objectives &amp; Approach</a:t>
             </a:r>
           </a:p>
           <a:p>
             <a:pPr>
               <a:spcAft>
-                <a:spcPts val="400"/>
-              </a:spcAft>
-              <a:defRPr sz="1200">
+                <a:spcPts val="350"/>
+              </a:spcAft>
+              <a:defRPr sz="1300">
                 <a:solidFill>
                   <a:srgbClr val="212529"/>
                 </a:solidFill>
@@ -16872,15 +16872,15 @@
               </a:defRPr>
             </a:pPr>
             <a:r>
-              <a:t>3. Literature Survey (12 IEEE / Scopus Papers)  --  Critical Analysis &amp; Comparative Matrix (Rubric: 3 Marks)</a:t>
+              <a:t>3. Literature Survey (12 IEEE / Scopus Papers)  --  Critical Analysis &amp; Comparative Matrix</a:t>
             </a:r>
           </a:p>
           <a:p>
             <a:pPr>
               <a:spcAft>
-                <a:spcPts val="400"/>
-              </a:spcAft>
-              <a:defRPr sz="1200">
+                <a:spcPts val="350"/>
+              </a:spcAft>
+              <a:defRPr sz="1300">
                 <a:solidFill>
                   <a:srgbClr val="212529"/>
                 </a:solidFill>
@@ -16888,15 +16888,15 @@
               </a:defRPr>
             </a:pPr>
             <a:r>
-              <a:t>4. Project Objectives  --  SMART Outcome-Focused Goals (Rubric: 2 Marks)</a:t>
+              <a:t>4. Project Objectives  --  SMART Outcome-Focused Goals</a:t>
             </a:r>
           </a:p>
           <a:p>
             <a:pPr>
               <a:spcAft>
-                <a:spcPts val="400"/>
-              </a:spcAft>
-              <a:defRPr sz="1200">
+                <a:spcPts val="350"/>
+              </a:spcAft>
+              <a:defRPr sz="1300">
                 <a:solidFill>
                   <a:srgbClr val="212529"/>
                 </a:solidFill>
@@ -16904,15 +16904,15 @@
               </a:defRPr>
             </a:pPr>
             <a:r>
-              <a:t>5. Existing Methods and Drawbacks  --  Comparative Critique of Current Approaches (Rubric: 2 Marks)</a:t>
+              <a:t>5. Existing Methods and Drawbacks  --  Comparative Critique of Current Approaches</a:t>
             </a:r>
           </a:p>
           <a:p>
             <a:pPr>
               <a:spcAft>
-                <a:spcPts val="400"/>
-              </a:spcAft>
-              <a:defRPr sz="1200">
+                <a:spcPts val="350"/>
+              </a:spcAft>
+              <a:defRPr sz="1300">
                 <a:solidFill>
                   <a:srgbClr val="212529"/>
                 </a:solidFill>
@@ -16920,15 +16920,15 @@
               </a:defRPr>
             </a:pPr>
             <a:r>
-              <a:t>6. Proposed Method &amp; Feasibility Study  --  Cross-Source NLI &amp; Technical/Cost Feasibility (Rubric: 3 Marks)</a:t>
+              <a:t>6. Proposed Method &amp; Feasibility Study  --  Cross-Source NLI &amp; Technical / Cost Feasibility</a:t>
             </a:r>
           </a:p>
           <a:p>
             <a:pPr>
               <a:spcAft>
-                <a:spcPts val="400"/>
-              </a:spcAft>
-              <a:defRPr sz="1200">
+                <a:spcPts val="350"/>
+              </a:spcAft>
+              <a:defRPr sz="1300">
                 <a:solidFill>
                   <a:srgbClr val="212529"/>
                 </a:solidFill>
@@ -16936,15 +16936,15 @@
               </a:defRPr>
             </a:pPr>
             <a:r>
-              <a:t>7. System Architecture Diagram  --  3-Tier Dataflow &amp; Model Integration (Rubric: 3 Marks)</a:t>
+              <a:t>7. System Architecture Diagram  --  3-Tier Dataflow &amp; Model Integration</a:t>
             </a:r>
           </a:p>
           <a:p>
             <a:pPr>
               <a:spcAft>
-                <a:spcPts val="400"/>
-              </a:spcAft>
-              <a:defRPr sz="1200">
+                <a:spcPts val="350"/>
+              </a:spcAft>
+              <a:defRPr sz="1300">
                 <a:solidFill>
                   <a:srgbClr val="212529"/>
                 </a:solidFill>
@@ -16952,15 +16952,15 @@
               </a:defRPr>
             </a:pPr>
             <a:r>
-              <a:t>8. System Modules Breakdown  --  Modules 1 to 6 Functional Details (Rubric: 2 Marks)</a:t>
+              <a:t>8. System Modules Breakdown  --  Modules 1 to 6 Functional Details</a:t>
             </a:r>
           </a:p>
           <a:p>
             <a:pPr>
               <a:spcAft>
-                <a:spcPts val="400"/>
-              </a:spcAft>
-              <a:defRPr sz="1200">
+                <a:spcPts val="350"/>
+              </a:spcAft>
+              <a:defRPr sz="1300">
                 <a:solidFill>
                   <a:srgbClr val="212529"/>
                 </a:solidFill>
@@ -16968,15 +16968,15 @@
               </a:defRPr>
             </a:pPr>
             <a:r>
-              <a:t>9. Hardware and Software Details  --  Tech Stack, Dependencies &amp; Hardware Specs (Rubric: 1 Mark)</a:t>
+              <a:t>9. Hardware and Software Details  --  Tech Stack, Dependencies &amp; Hardware Specs</a:t>
             </a:r>
           </a:p>
           <a:p>
             <a:pPr>
               <a:spcAft>
-                <a:spcPts val="400"/>
-              </a:spcAft>
-              <a:defRPr sz="1200">
+                <a:spcPts val="350"/>
+              </a:spcAft>
+              <a:defRPr sz="1300">
                 <a:solidFill>
                   <a:srgbClr val="212529"/>
                 </a:solidFill>
@@ -16984,15 +16984,15 @@
               </a:defRPr>
             </a:pPr>
             <a:r>
-              <a:t>10. Timeline of the Project (Gantt Chart)  --  5-Phase Development Plan &amp; Milestones (Rubric: 1 Mark)</a:t>
+              <a:t>10. Timeline of the Project (Gantt Chart)  --  5-Phase Development Plan &amp; Milestones</a:t>
             </a:r>
           </a:p>
           <a:p>
             <a:pPr>
               <a:spcAft>
-                <a:spcPts val="400"/>
-              </a:spcAft>
-              <a:defRPr sz="1200">
+                <a:spcPts val="350"/>
+              </a:spcAft>
+              <a:defRPr sz="1300">
                 <a:solidFill>
                   <a:srgbClr val="212529"/>
                 </a:solidFill>
@@ -17000,15 +17000,15 @@
               </a:defRPr>
             </a:pPr>
             <a:r>
-              <a:t>11. References  --  IEEE Standard Citation Format (Rubric: 1 Mark)</a:t>
+              <a:t>11. References  --  IEEE Standard Citation Format</a:t>
             </a:r>
           </a:p>
           <a:p>
             <a:pPr>
               <a:spcAft>
-                <a:spcPts val="400"/>
-              </a:spcAft>
-              <a:defRPr sz="1200">
+                <a:spcPts val="350"/>
+              </a:spcAft>
+              <a:defRPr sz="1300">
                 <a:solidFill>
                   <a:srgbClr val="212529"/>
                 </a:solidFill>
@@ -17016,7 +17016,7 @@
               </a:defRPr>
             </a:pPr>
             <a:r>
-              <a:t>12. Review 2 Phase Deliverables &amp; Live Demo  --  MBFC SQLite Database &amp; Baseline Verification</a:t>
+              <a:t>12. Review 2 Deliverables &amp; Demonstration  --  MBFC SQLite Database &amp; Verification Testbed</a:t>
             </a:r>
           </a:p>
         </p:txBody>
@@ -17055,7 +17055,7 @@
         <p:spPr>
           <a:xfrm>
             <a:off x="731520" y="365760"/>
-            <a:ext cx="10515600" cy="822960"/>
+            <a:ext cx="10789920" cy="822960"/>
           </a:xfrm>
           <a:prstGeom prst="rect">
             <a:avLst/>
@@ -17069,7 +17069,7 @@
           <a:lstStyle/>
           <a:p>
             <a:pPr>
-              <a:defRPr sz="2400" b="1">
+              <a:defRPr sz="2600" b="1">
                 <a:solidFill>
                   <a:srgbClr val="102C57"/>
                 </a:solidFill>
@@ -17090,8 +17090,8 @@
         </p:nvSpPr>
         <p:spPr>
           <a:xfrm>
-            <a:off x="731520" y="1280160"/>
-            <a:ext cx="10515600" cy="5029200"/>
+            <a:off x="731520" y="1188720"/>
+            <a:ext cx="10789920" cy="5120640"/>
           </a:xfrm>
           <a:prstGeom prst="rect">
             <a:avLst/>
@@ -17106,9 +17106,9 @@
           <a:p>
             <a:pPr>
               <a:spcAft>
-                <a:spcPts val="1000"/>
-              </a:spcAft>
-              <a:defRPr sz="1600" b="1">
+                <a:spcPts val="1200"/>
+              </a:spcAft>
+              <a:defRPr sz="1800" b="1">
                 <a:solidFill>
                   <a:srgbClr val="102C57"/>
                 </a:solidFill>
@@ -17126,7 +17126,7 @@
               </a:spcAft>
             </a:pPr>
             <a:r>
-              <a:rPr b="1" sz="1400">
+              <a:rPr b="1" sz="1500">
                 <a:solidFill>
                   <a:srgbClr val="102C57"/>
                 </a:solidFill>
@@ -17134,7 +17134,7 @@
               <a:t>Organization: </a:t>
             </a:r>
             <a:r>
-              <a:rPr b="0" sz="1400">
+              <a:rPr b="0" sz="1500">
                 <a:solidFill>
                   <a:srgbClr val="212529"/>
                 </a:solidFill>
@@ -17149,7 +17149,7 @@
               </a:spcAft>
             </a:pPr>
             <a:r>
-              <a:rPr b="1" sz="1400">
+              <a:rPr b="1" sz="1500">
                 <a:solidFill>
                   <a:srgbClr val="102C57"/>
                 </a:solidFill>
@@ -17157,7 +17157,7 @@
               <a:t>Category: </a:t>
             </a:r>
             <a:r>
-              <a:rPr b="0" sz="1400">
+              <a:rPr b="0" sz="1500">
                 <a:solidFill>
                   <a:srgbClr val="212529"/>
                 </a:solidFill>
@@ -17172,7 +17172,7 @@
               </a:spcAft>
             </a:pPr>
             <a:r>
-              <a:rPr b="1" sz="1400">
+              <a:rPr b="1" sz="1500">
                 <a:solidFill>
                   <a:srgbClr val="102C57"/>
                 </a:solidFill>
@@ -17180,7 +17180,7 @@
               <a:t>Difficulty Level: </a:t>
             </a:r>
             <a:r>
-              <a:rPr b="0" sz="1400">
+              <a:rPr b="0" sz="1500">
                 <a:solidFill>
                   <a:srgbClr val="212529"/>
                 </a:solidFill>
@@ -17195,7 +17195,7 @@
               </a:spcAft>
             </a:pPr>
             <a:r>
-              <a:rPr b="1" sz="1400">
+              <a:rPr b="1" sz="1500">
                 <a:solidFill>
                   <a:srgbClr val="102C57"/>
                 </a:solidFill>
@@ -17203,7 +17203,7 @@
               <a:t>Problem Description: </a:t>
             </a:r>
             <a:r>
-              <a:rPr b="0" sz="1400">
+              <a:rPr b="0" sz="1500">
                 <a:solidFill>
                   <a:srgbClr val="212529"/>
                 </a:solidFill>
@@ -17218,7 +17218,7 @@
               </a:spcAft>
             </a:pPr>
             <a:r>
-              <a:rPr b="1" sz="1400">
+              <a:rPr b="1" sz="1500">
                 <a:solidFill>
                   <a:srgbClr val="3565A9"/>
                 </a:solidFill>
@@ -17226,7 +17226,7 @@
               <a:t>Official GitHub Repository: </a:t>
             </a:r>
             <a:r>
-              <a:rPr b="1" sz="1400">
+              <a:rPr b="1" sz="1500">
                 <a:solidFill>
                   <a:srgbClr val="28A745"/>
                 </a:solidFill>
@@ -17275,7 +17275,7 @@
         <p:spPr>
           <a:xfrm>
             <a:off x="731520" y="365760"/>
-            <a:ext cx="10515600" cy="822960"/>
+            <a:ext cx="10789920" cy="822960"/>
           </a:xfrm>
           <a:prstGeom prst="rect">
             <a:avLst/>
@@ -17289,7 +17289,7 @@
           <a:lstStyle/>
           <a:p>
             <a:pPr>
-              <a:defRPr sz="2400" b="1">
+              <a:defRPr sz="2600" b="1">
                 <a:solidFill>
                   <a:srgbClr val="102C57"/>
                 </a:solidFill>
@@ -17297,7 +17297,7 @@
               </a:defRPr>
             </a:pPr>
             <a:r>
-              <a:t>Abstract (Rubric: 2 Marks)</a:t>
+              <a:t>Abstract</a:t>
             </a:r>
           </a:p>
         </p:txBody>
@@ -17310,8 +17310,8 @@
         </p:nvSpPr>
         <p:spPr>
           <a:xfrm>
-            <a:off x="731520" y="1280160"/>
-            <a:ext cx="10515600" cy="5029200"/>
+            <a:off x="731520" y="1188720"/>
+            <a:ext cx="10789920" cy="5120640"/>
           </a:xfrm>
           <a:prstGeom prst="rect">
             <a:avLst/>
@@ -17330,7 +17330,7 @@
               </a:spcAft>
             </a:pPr>
             <a:r>
-              <a:rPr b="1" sz="1300">
+              <a:rPr b="1" sz="1400">
                 <a:solidFill>
                   <a:srgbClr val="102C57"/>
                 </a:solidFill>
@@ -17338,7 +17338,7 @@
               <a:t>Problem Context: </a:t>
             </a:r>
             <a:r>
-              <a:rPr sz="1300">
+              <a:rPr sz="1400">
                 <a:solidFill>
                   <a:srgbClr val="212529"/>
                 </a:solidFill>
@@ -17353,7 +17353,7 @@
               </a:spcAft>
             </a:pPr>
             <a:r>
-              <a:rPr b="1" sz="1300">
+              <a:rPr b="1" sz="1400">
                 <a:solidFill>
                   <a:srgbClr val="102C57"/>
                 </a:solidFill>
@@ -17361,7 +17361,7 @@
               <a:t>Core Project Objective: </a:t>
             </a:r>
             <a:r>
-              <a:rPr sz="1300">
+              <a:rPr sz="1400">
                 <a:solidFill>
                   <a:srgbClr val="212529"/>
                 </a:solidFill>
@@ -17376,7 +17376,7 @@
               </a:spcAft>
             </a:pPr>
             <a:r>
-              <a:rPr b="1" sz="1300">
+              <a:rPr b="1" sz="1400">
                 <a:solidFill>
                   <a:srgbClr val="102C57"/>
                 </a:solidFill>
@@ -17384,7 +17384,7 @@
               <a:t>Proposed Approach &amp; Workflow: </a:t>
             </a:r>
             <a:r>
-              <a:rPr sz="1300">
+              <a:rPr sz="1400">
                 <a:solidFill>
                   <a:srgbClr val="212529"/>
                 </a:solidFill>
@@ -17399,7 +17399,7 @@
               </a:spcAft>
             </a:pPr>
             <a:r>
-              <a:rPr b="1" sz="1300">
+              <a:rPr b="1" sz="1400">
                 <a:solidFill>
                   <a:srgbClr val="102C57"/>
                 </a:solidFill>
@@ -17407,7 +17407,7 @@
               <a:t>Deliverables &amp; Impact: </a:t>
             </a:r>
             <a:r>
-              <a:rPr sz="1300">
+              <a:rPr sz="1400">
                 <a:solidFill>
                   <a:srgbClr val="212529"/>
                 </a:solidFill>
@@ -17456,7 +17456,7 @@
         <p:spPr>
           <a:xfrm>
             <a:off x="731520" y="365760"/>
-            <a:ext cx="10515600" cy="822960"/>
+            <a:ext cx="10789920" cy="822960"/>
           </a:xfrm>
           <a:prstGeom prst="rect">
             <a:avLst/>
@@ -17470,7 +17470,7 @@
           <a:lstStyle/>
           <a:p>
             <a:pPr>
-              <a:defRPr sz="2400" b="1">
+              <a:defRPr sz="2600" b="1">
                 <a:solidFill>
                   <a:srgbClr val="102C57"/>
                 </a:solidFill>
@@ -17478,7 +17478,7 @@
               </a:defRPr>
             </a:pPr>
             <a:r>
-              <a:t>Literature Survey -- Part 1 (Rubric: 3 Marks)</a:t>
+              <a:t>Literature Survey -- Part 1</a:t>
             </a:r>
           </a:p>
         </p:txBody>
@@ -17515,7 +17515,7 @@
                     <a:lstStyle/>
                     <a:p>
                       <a:pPr algn="l">
-                        <a:defRPr sz="1000" b="1">
+                        <a:defRPr sz="1100" b="1">
                           <a:solidFill>
                             <a:srgbClr val="FFFFFF"/>
                           </a:solidFill>
@@ -17539,7 +17539,7 @@
                     <a:lstStyle/>
                     <a:p>
                       <a:pPr algn="l">
-                        <a:defRPr sz="1000" b="1">
+                        <a:defRPr sz="1100" b="1">
                           <a:solidFill>
                             <a:srgbClr val="FFFFFF"/>
                           </a:solidFill>
@@ -17563,7 +17563,7 @@
                     <a:lstStyle/>
                     <a:p>
                       <a:pPr algn="l">
-                        <a:defRPr sz="1000" b="1">
+                        <a:defRPr sz="1100" b="1">
                           <a:solidFill>
                             <a:srgbClr val="FFFFFF"/>
                           </a:solidFill>
@@ -17587,7 +17587,7 @@
                     <a:lstStyle/>
                     <a:p>
                       <a:pPr algn="l">
-                        <a:defRPr sz="1000" b="1">
+                        <a:defRPr sz="1100" b="1">
                           <a:solidFill>
                             <a:srgbClr val="FFFFFF"/>
                           </a:solidFill>
@@ -17611,7 +17611,7 @@
                     <a:lstStyle/>
                     <a:p>
                       <a:pPr algn="l">
-                        <a:defRPr sz="1000" b="1">
+                        <a:defRPr sz="1100" b="1">
                           <a:solidFill>
                             <a:srgbClr val="FFFFFF"/>
                           </a:solidFill>
@@ -17637,7 +17637,7 @@
                     <a:lstStyle/>
                     <a:p>
                       <a:pPr algn="l">
-                        <a:defRPr sz="900" b="0">
+                        <a:defRPr sz="1000" b="0">
                           <a:solidFill>
                             <a:srgbClr val="212529"/>
                           </a:solidFill>
@@ -17666,7 +17666,7 @@
                     <a:lstStyle/>
                     <a:p>
                       <a:pPr algn="l">
-                        <a:defRPr sz="900" b="0">
+                        <a:defRPr sz="1000" b="0">
                           <a:solidFill>
                             <a:srgbClr val="212529"/>
                           </a:solidFill>
@@ -17690,7 +17690,7 @@
                     <a:lstStyle/>
                     <a:p>
                       <a:pPr algn="l">
-                        <a:defRPr sz="900" b="0">
+                        <a:defRPr sz="1000" b="0">
                           <a:solidFill>
                             <a:srgbClr val="212529"/>
                           </a:solidFill>
@@ -17714,7 +17714,7 @@
                     <a:lstStyle/>
                     <a:p>
                       <a:pPr algn="l">
-                        <a:defRPr sz="900" b="0">
+                        <a:defRPr sz="1000" b="0">
                           <a:solidFill>
                             <a:srgbClr val="212529"/>
                           </a:solidFill>
@@ -17738,7 +17738,7 @@
                     <a:lstStyle/>
                     <a:p>
                       <a:pPr algn="l">
-                        <a:defRPr sz="900" b="0">
+                        <a:defRPr sz="1000" b="0">
                           <a:solidFill>
                             <a:srgbClr val="212529"/>
                           </a:solidFill>
@@ -17764,7 +17764,7 @@
                     <a:lstStyle/>
                     <a:p>
                       <a:pPr algn="l">
-                        <a:defRPr sz="900" b="0">
+                        <a:defRPr sz="1000" b="0">
                           <a:solidFill>
                             <a:srgbClr val="212529"/>
                           </a:solidFill>
@@ -17789,7 +17789,7 @@
                     <a:lstStyle/>
                     <a:p>
                       <a:pPr algn="l">
-                        <a:defRPr sz="900" b="0">
+                        <a:defRPr sz="1000" b="0">
                           <a:solidFill>
                             <a:srgbClr val="212529"/>
                           </a:solidFill>
@@ -17809,7 +17809,7 @@
                     <a:lstStyle/>
                     <a:p>
                       <a:pPr algn="l">
-                        <a:defRPr sz="900" b="0">
+                        <a:defRPr sz="1000" b="0">
                           <a:solidFill>
                             <a:srgbClr val="212529"/>
                           </a:solidFill>
@@ -17829,7 +17829,7 @@
                     <a:lstStyle/>
                     <a:p>
                       <a:pPr algn="l">
-                        <a:defRPr sz="900" b="0">
+                        <a:defRPr sz="1000" b="0">
                           <a:solidFill>
                             <a:srgbClr val="212529"/>
                           </a:solidFill>
@@ -17849,7 +17849,7 @@
                     <a:lstStyle/>
                     <a:p>
                       <a:pPr algn="l">
-                        <a:defRPr sz="900" b="0">
+                        <a:defRPr sz="1000" b="0">
                           <a:solidFill>
                             <a:srgbClr val="212529"/>
                           </a:solidFill>
@@ -17871,7 +17871,7 @@
                     <a:lstStyle/>
                     <a:p>
                       <a:pPr algn="l">
-                        <a:defRPr sz="900" b="0">
+                        <a:defRPr sz="1000" b="0">
                           <a:solidFill>
                             <a:srgbClr val="212529"/>
                           </a:solidFill>
@@ -17900,7 +17900,7 @@
                     <a:lstStyle/>
                     <a:p>
                       <a:pPr algn="l">
-                        <a:defRPr sz="900" b="0">
+                        <a:defRPr sz="1000" b="0">
                           <a:solidFill>
                             <a:srgbClr val="212529"/>
                           </a:solidFill>
@@ -17924,7 +17924,7 @@
                     <a:lstStyle/>
                     <a:p>
                       <a:pPr algn="l">
-                        <a:defRPr sz="900" b="0">
+                        <a:defRPr sz="1000" b="0">
                           <a:solidFill>
                             <a:srgbClr val="212529"/>
                           </a:solidFill>
@@ -17948,7 +17948,7 @@
                     <a:lstStyle/>
                     <a:p>
                       <a:pPr algn="l">
-                        <a:defRPr sz="900" b="0">
+                        <a:defRPr sz="1000" b="0">
                           <a:solidFill>
                             <a:srgbClr val="212529"/>
                           </a:solidFill>
@@ -17972,7 +17972,7 @@
                     <a:lstStyle/>
                     <a:p>
                       <a:pPr algn="l">
-                        <a:defRPr sz="900" b="0">
+                        <a:defRPr sz="1000" b="0">
                           <a:solidFill>
                             <a:srgbClr val="212529"/>
                           </a:solidFill>
@@ -17998,7 +17998,7 @@
                     <a:lstStyle/>
                     <a:p>
                       <a:pPr algn="l">
-                        <a:defRPr sz="900" b="0">
+                        <a:defRPr sz="1000" b="0">
                           <a:solidFill>
                             <a:srgbClr val="212529"/>
                           </a:solidFill>
@@ -18023,7 +18023,7 @@
                     <a:lstStyle/>
                     <a:p>
                       <a:pPr algn="l">
-                        <a:defRPr sz="900" b="0">
+                        <a:defRPr sz="1000" b="0">
                           <a:solidFill>
                             <a:srgbClr val="212529"/>
                           </a:solidFill>
@@ -18043,7 +18043,7 @@
                     <a:lstStyle/>
                     <a:p>
                       <a:pPr algn="l">
-                        <a:defRPr sz="900" b="0">
+                        <a:defRPr sz="1000" b="0">
                           <a:solidFill>
                             <a:srgbClr val="212529"/>
                           </a:solidFill>
@@ -18063,7 +18063,7 @@
                     <a:lstStyle/>
                     <a:p>
                       <a:pPr algn="l">
-                        <a:defRPr sz="900" b="0">
+                        <a:defRPr sz="1000" b="0">
                           <a:solidFill>
                             <a:srgbClr val="212529"/>
                           </a:solidFill>
@@ -18083,7 +18083,7 @@
                     <a:lstStyle/>
                     <a:p>
                       <a:pPr algn="l">
-                        <a:defRPr sz="900" b="0">
+                        <a:defRPr sz="1000" b="0">
                           <a:solidFill>
                             <a:srgbClr val="212529"/>
                           </a:solidFill>
@@ -18105,7 +18105,7 @@
                     <a:lstStyle/>
                     <a:p>
                       <a:pPr algn="l">
-                        <a:defRPr sz="900" b="0">
+                        <a:defRPr sz="1000" b="0">
                           <a:solidFill>
                             <a:srgbClr val="212529"/>
                           </a:solidFill>
@@ -18134,7 +18134,7 @@
                     <a:lstStyle/>
                     <a:p>
                       <a:pPr algn="l">
-                        <a:defRPr sz="900" b="0">
+                        <a:defRPr sz="1000" b="0">
                           <a:solidFill>
                             <a:srgbClr val="212529"/>
                           </a:solidFill>
@@ -18158,7 +18158,7 @@
                     <a:lstStyle/>
                     <a:p>
                       <a:pPr algn="l">
-                        <a:defRPr sz="900" b="0">
+                        <a:defRPr sz="1000" b="0">
                           <a:solidFill>
                             <a:srgbClr val="212529"/>
                           </a:solidFill>
@@ -18182,7 +18182,7 @@
                     <a:lstStyle/>
                     <a:p>
                       <a:pPr algn="l">
-                        <a:defRPr sz="900" b="0">
+                        <a:defRPr sz="1000" b="0">
                           <a:solidFill>
                             <a:srgbClr val="212529"/>
                           </a:solidFill>
@@ -18206,7 +18206,7 @@
                     <a:lstStyle/>
                     <a:p>
                       <a:pPr algn="l">
-                        <a:defRPr sz="900" b="0">
+                        <a:defRPr sz="1000" b="0">
                           <a:solidFill>
                             <a:srgbClr val="212529"/>
                           </a:solidFill>
@@ -18232,7 +18232,7 @@
                     <a:lstStyle/>
                     <a:p>
                       <a:pPr algn="l">
-                        <a:defRPr sz="900" b="0">
+                        <a:defRPr sz="1000" b="0">
                           <a:solidFill>
                             <a:srgbClr val="212529"/>
                           </a:solidFill>
@@ -18257,7 +18257,7 @@
                     <a:lstStyle/>
                     <a:p>
                       <a:pPr algn="l">
-                        <a:defRPr sz="900" b="0">
+                        <a:defRPr sz="1000" b="0">
                           <a:solidFill>
                             <a:srgbClr val="212529"/>
                           </a:solidFill>
@@ -18277,7 +18277,7 @@
                     <a:lstStyle/>
                     <a:p>
                       <a:pPr algn="l">
-                        <a:defRPr sz="900" b="0">
+                        <a:defRPr sz="1000" b="0">
                           <a:solidFill>
                             <a:srgbClr val="212529"/>
                           </a:solidFill>
@@ -18297,7 +18297,7 @@
                     <a:lstStyle/>
                     <a:p>
                       <a:pPr algn="l">
-                        <a:defRPr sz="900" b="0">
+                        <a:defRPr sz="1000" b="0">
                           <a:solidFill>
                             <a:srgbClr val="212529"/>
                           </a:solidFill>
@@ -18317,7 +18317,7 @@
                     <a:lstStyle/>
                     <a:p>
                       <a:pPr algn="l">
-                        <a:defRPr sz="900" b="0">
+                        <a:defRPr sz="1000" b="0">
                           <a:solidFill>
                             <a:srgbClr val="212529"/>
                           </a:solidFill>
@@ -18375,7 +18375,7 @@
         <p:spPr>
           <a:xfrm>
             <a:off x="731520" y="365760"/>
-            <a:ext cx="10515600" cy="822960"/>
+            <a:ext cx="10789920" cy="822960"/>
           </a:xfrm>
           <a:prstGeom prst="rect">
             <a:avLst/>
@@ -18389,7 +18389,7 @@
           <a:lstStyle/>
           <a:p>
             <a:pPr>
-              <a:defRPr sz="2400" b="1">
+              <a:defRPr sz="2600" b="1">
                 <a:solidFill>
                   <a:srgbClr val="102C57"/>
                 </a:solidFill>
@@ -18397,7 +18397,7 @@
               </a:defRPr>
             </a:pPr>
             <a:r>
-              <a:t>Literature Survey -- Part 2 (Rubric: 3 Marks)</a:t>
+              <a:t>Literature Survey -- Part 2</a:t>
             </a:r>
           </a:p>
         </p:txBody>
@@ -18434,7 +18434,7 @@
                     <a:lstStyle/>
                     <a:p>
                       <a:pPr algn="l">
-                        <a:defRPr sz="1000" b="1">
+                        <a:defRPr sz="1100" b="1">
                           <a:solidFill>
                             <a:srgbClr val="FFFFFF"/>
                           </a:solidFill>
@@ -18458,7 +18458,7 @@
                     <a:lstStyle/>
                     <a:p>
                       <a:pPr algn="l">
-                        <a:defRPr sz="1000" b="1">
+                        <a:defRPr sz="1100" b="1">
                           <a:solidFill>
                             <a:srgbClr val="FFFFFF"/>
                           </a:solidFill>
@@ -18482,7 +18482,7 @@
                     <a:lstStyle/>
                     <a:p>
                       <a:pPr algn="l">
-                        <a:defRPr sz="1000" b="1">
+                        <a:defRPr sz="1100" b="1">
                           <a:solidFill>
                             <a:srgbClr val="FFFFFF"/>
                           </a:solidFill>
@@ -18506,7 +18506,7 @@
                     <a:lstStyle/>
                     <a:p>
                       <a:pPr algn="l">
-                        <a:defRPr sz="1000" b="1">
+                        <a:defRPr sz="1100" b="1">
                           <a:solidFill>
                             <a:srgbClr val="FFFFFF"/>
                           </a:solidFill>
@@ -18530,7 +18530,7 @@
                     <a:lstStyle/>
                     <a:p>
                       <a:pPr algn="l">
-                        <a:defRPr sz="1000" b="1">
+                        <a:defRPr sz="1100" b="1">
                           <a:solidFill>
                             <a:srgbClr val="FFFFFF"/>
                           </a:solidFill>
@@ -18556,7 +18556,7 @@
                     <a:lstStyle/>
                     <a:p>
                       <a:pPr algn="l">
-                        <a:defRPr sz="900" b="0">
+                        <a:defRPr sz="1000" b="0">
                           <a:solidFill>
                             <a:srgbClr val="212529"/>
                           </a:solidFill>
@@ -18585,7 +18585,7 @@
                     <a:lstStyle/>
                     <a:p>
                       <a:pPr algn="l">
-                        <a:defRPr sz="900" b="0">
+                        <a:defRPr sz="1000" b="0">
                           <a:solidFill>
                             <a:srgbClr val="212529"/>
                           </a:solidFill>
@@ -18609,7 +18609,7 @@
                     <a:lstStyle/>
                     <a:p>
                       <a:pPr algn="l">
-                        <a:defRPr sz="900" b="0">
+                        <a:defRPr sz="1000" b="0">
                           <a:solidFill>
                             <a:srgbClr val="212529"/>
                           </a:solidFill>
@@ -18633,7 +18633,7 @@
                     <a:lstStyle/>
                     <a:p>
                       <a:pPr algn="l">
-                        <a:defRPr sz="900" b="0">
+                        <a:defRPr sz="1000" b="0">
                           <a:solidFill>
                             <a:srgbClr val="212529"/>
                           </a:solidFill>
@@ -18657,7 +18657,7 @@
                     <a:lstStyle/>
                     <a:p>
                       <a:pPr algn="l">
-                        <a:defRPr sz="900" b="0">
+                        <a:defRPr sz="1000" b="0">
                           <a:solidFill>
                             <a:srgbClr val="212529"/>
                           </a:solidFill>
@@ -18683,7 +18683,7 @@
                     <a:lstStyle/>
                     <a:p>
                       <a:pPr algn="l">
-                        <a:defRPr sz="900" b="0">
+                        <a:defRPr sz="1000" b="0">
                           <a:solidFill>
                             <a:srgbClr val="212529"/>
                           </a:solidFill>
@@ -18708,7 +18708,7 @@
                     <a:lstStyle/>
                     <a:p>
                       <a:pPr algn="l">
-                        <a:defRPr sz="900" b="0">
+                        <a:defRPr sz="1000" b="0">
                           <a:solidFill>
                             <a:srgbClr val="212529"/>
                           </a:solidFill>
@@ -18728,7 +18728,7 @@
                     <a:lstStyle/>
                     <a:p>
                       <a:pPr algn="l">
-                        <a:defRPr sz="900" b="0">
+                        <a:defRPr sz="1000" b="0">
                           <a:solidFill>
                             <a:srgbClr val="212529"/>
                           </a:solidFill>
@@ -18748,7 +18748,7 @@
                     <a:lstStyle/>
                     <a:p>
                       <a:pPr algn="l">
-                        <a:defRPr sz="900" b="0">
+                        <a:defRPr sz="1000" b="0">
                           <a:solidFill>
                             <a:srgbClr val="212529"/>
                           </a:solidFill>
@@ -18768,7 +18768,7 @@
                     <a:lstStyle/>
                     <a:p>
                       <a:pPr algn="l">
-                        <a:defRPr sz="900" b="0">
+                        <a:defRPr sz="1000" b="0">
                           <a:solidFill>
                             <a:srgbClr val="212529"/>
                           </a:solidFill>
@@ -18790,7 +18790,7 @@
                     <a:lstStyle/>
                     <a:p>
                       <a:pPr algn="l">
-                        <a:defRPr sz="900" b="0">
+                        <a:defRPr sz="1000" b="0">
                           <a:solidFill>
                             <a:srgbClr val="212529"/>
                           </a:solidFill>
@@ -18819,7 +18819,7 @@
                     <a:lstStyle/>
                     <a:p>
                       <a:pPr algn="l">
-                        <a:defRPr sz="900" b="0">
+                        <a:defRPr sz="1000" b="0">
                           <a:solidFill>
                             <a:srgbClr val="212529"/>
                           </a:solidFill>
@@ -18843,7 +18843,7 @@
                     <a:lstStyle/>
                     <a:p>
                       <a:pPr algn="l">
-                        <a:defRPr sz="900" b="0">
+                        <a:defRPr sz="1000" b="0">
                           <a:solidFill>
                             <a:srgbClr val="212529"/>
                           </a:solidFill>
@@ -18867,7 +18867,7 @@
                     <a:lstStyle/>
                     <a:p>
                       <a:pPr algn="l">
-                        <a:defRPr sz="900" b="0">
+                        <a:defRPr sz="1000" b="0">
                           <a:solidFill>
                             <a:srgbClr val="212529"/>
                           </a:solidFill>
@@ -18891,7 +18891,7 @@
                     <a:lstStyle/>
                     <a:p>
                       <a:pPr algn="l">
-                        <a:defRPr sz="900" b="0">
+                        <a:defRPr sz="1000" b="0">
                           <a:solidFill>
                             <a:srgbClr val="212529"/>
                           </a:solidFill>
@@ -18917,7 +18917,7 @@
                     <a:lstStyle/>
                     <a:p>
                       <a:pPr algn="l">
-                        <a:defRPr sz="900" b="0">
+                        <a:defRPr sz="1000" b="0">
                           <a:solidFill>
                             <a:srgbClr val="212529"/>
                           </a:solidFill>
@@ -18942,7 +18942,7 @@
                     <a:lstStyle/>
                     <a:p>
                       <a:pPr algn="l">
-                        <a:defRPr sz="900" b="0">
+                        <a:defRPr sz="1000" b="0">
                           <a:solidFill>
                             <a:srgbClr val="212529"/>
                           </a:solidFill>
@@ -18962,7 +18962,7 @@
                     <a:lstStyle/>
                     <a:p>
                       <a:pPr algn="l">
-                        <a:defRPr sz="900" b="0">
+                        <a:defRPr sz="1000" b="0">
                           <a:solidFill>
                             <a:srgbClr val="212529"/>
                           </a:solidFill>
@@ -18982,7 +18982,7 @@
                     <a:lstStyle/>
                     <a:p>
                       <a:pPr algn="l">
-                        <a:defRPr sz="900" b="0">
+                        <a:defRPr sz="1000" b="0">
                           <a:solidFill>
                             <a:srgbClr val="212529"/>
                           </a:solidFill>
@@ -19002,7 +19002,7 @@
                     <a:lstStyle/>
                     <a:p>
                       <a:pPr algn="l">
-                        <a:defRPr sz="900" b="0">
+                        <a:defRPr sz="1000" b="0">
                           <a:solidFill>
                             <a:srgbClr val="212529"/>
                           </a:solidFill>
@@ -19024,7 +19024,7 @@
                     <a:lstStyle/>
                     <a:p>
                       <a:pPr algn="l">
-                        <a:defRPr sz="900" b="0">
+                        <a:defRPr sz="1000" b="0">
                           <a:solidFill>
                             <a:srgbClr val="212529"/>
                           </a:solidFill>
@@ -19053,7 +19053,7 @@
                     <a:lstStyle/>
                     <a:p>
                       <a:pPr algn="l">
-                        <a:defRPr sz="900" b="0">
+                        <a:defRPr sz="1000" b="0">
                           <a:solidFill>
                             <a:srgbClr val="212529"/>
                           </a:solidFill>
@@ -19077,7 +19077,7 @@
                     <a:lstStyle/>
                     <a:p>
                       <a:pPr algn="l">
-                        <a:defRPr sz="900" b="0">
+                        <a:defRPr sz="1000" b="0">
                           <a:solidFill>
                             <a:srgbClr val="212529"/>
                           </a:solidFill>
@@ -19101,7 +19101,7 @@
                     <a:lstStyle/>
                     <a:p>
                       <a:pPr algn="l">
-                        <a:defRPr sz="900" b="0">
+                        <a:defRPr sz="1000" b="0">
                           <a:solidFill>
                             <a:srgbClr val="212529"/>
                           </a:solidFill>
@@ -19125,7 +19125,7 @@
                     <a:lstStyle/>
                     <a:p>
                       <a:pPr algn="l">
-                        <a:defRPr sz="900" b="0">
+                        <a:defRPr sz="1000" b="0">
                           <a:solidFill>
                             <a:srgbClr val="212529"/>
                           </a:solidFill>
@@ -19151,7 +19151,7 @@
                     <a:lstStyle/>
                     <a:p>
                       <a:pPr algn="l">
-                        <a:defRPr sz="900" b="0">
+                        <a:defRPr sz="1000" b="0">
                           <a:solidFill>
                             <a:srgbClr val="212529"/>
                           </a:solidFill>
@@ -19176,7 +19176,7 @@
                     <a:lstStyle/>
                     <a:p>
                       <a:pPr algn="l">
-                        <a:defRPr sz="900" b="0">
+                        <a:defRPr sz="1000" b="0">
                           <a:solidFill>
                             <a:srgbClr val="212529"/>
                           </a:solidFill>
@@ -19196,7 +19196,7 @@
                     <a:lstStyle/>
                     <a:p>
                       <a:pPr algn="l">
-                        <a:defRPr sz="900" b="0">
+                        <a:defRPr sz="1000" b="0">
                           <a:solidFill>
                             <a:srgbClr val="212529"/>
                           </a:solidFill>
@@ -19216,7 +19216,7 @@
                     <a:lstStyle/>
                     <a:p>
                       <a:pPr algn="l">
-                        <a:defRPr sz="900" b="0">
+                        <a:defRPr sz="1000" b="0">
                           <a:solidFill>
                             <a:srgbClr val="212529"/>
                           </a:solidFill>
@@ -19236,7 +19236,7 @@
                     <a:lstStyle/>
                     <a:p>
                       <a:pPr algn="l">
-                        <a:defRPr sz="900" b="0">
+                        <a:defRPr sz="1000" b="0">
                           <a:solidFill>
                             <a:srgbClr val="212529"/>
                           </a:solidFill>
@@ -19294,7 +19294,7 @@
         <p:spPr>
           <a:xfrm>
             <a:off x="731520" y="365760"/>
-            <a:ext cx="10515600" cy="822960"/>
+            <a:ext cx="10789920" cy="822960"/>
           </a:xfrm>
           <a:prstGeom prst="rect">
             <a:avLst/>
@@ -19308,7 +19308,7 @@
           <a:lstStyle/>
           <a:p>
             <a:pPr>
-              <a:defRPr sz="2400" b="1">
+              <a:defRPr sz="2600" b="1">
                 <a:solidFill>
                   <a:srgbClr val="102C57"/>
                 </a:solidFill>
@@ -19316,7 +19316,7 @@
               </a:defRPr>
             </a:pPr>
             <a:r>
-              <a:t>Project Objectives (Rubric: 2 Marks)</a:t>
+              <a:t>Project Objectives</a:t>
             </a:r>
           </a:p>
         </p:txBody>
@@ -19330,7 +19330,7 @@
         <p:spPr>
           <a:xfrm>
             <a:off x="731520" y="1188720"/>
-            <a:ext cx="10515600" cy="5120640"/>
+            <a:ext cx="10789920" cy="5120640"/>
           </a:xfrm>
           <a:prstGeom prst="rect">
             <a:avLst/>
@@ -19345,11 +19345,11 @@
           <a:p>
             <a:pPr>
               <a:spcAft>
-                <a:spcPts val="600"/>
+                <a:spcPts val="700"/>
               </a:spcAft>
             </a:pPr>
             <a:r>
-              <a:rPr b="1" sz="1100">
+              <a:rPr b="1" sz="1250">
                 <a:solidFill>
                   <a:srgbClr val="102C57"/>
                 </a:solidFill>
@@ -19357,7 +19357,7 @@
               <a:t>Objective 1 -- Automated Factual Claim Extraction: </a:t>
             </a:r>
             <a:r>
-              <a:rPr sz="1100">
+              <a:rPr sz="1250">
                 <a:solidFill>
                   <a:srgbClr val="212529"/>
                 </a:solidFill>
@@ -19368,11 +19368,11 @@
           <a:p>
             <a:pPr>
               <a:spcAft>
-                <a:spcPts val="600"/>
+                <a:spcPts val="700"/>
               </a:spcAft>
             </a:pPr>
             <a:r>
-              <a:rPr b="1" sz="1100">
+              <a:rPr b="1" sz="1250">
                 <a:solidFill>
                   <a:srgbClr val="102C57"/>
                 </a:solidFill>
@@ -19380,7 +19380,7 @@
               <a:t>Objective 2 -- High-Speed Source Reputation Profiling: </a:t>
             </a:r>
             <a:r>
-              <a:rPr sz="1100">
+              <a:rPr sz="1250">
                 <a:solidFill>
                   <a:srgbClr val="212529"/>
                 </a:solidFill>
@@ -19391,11 +19391,11 @@
           <a:p>
             <a:pPr>
               <a:spcAft>
-                <a:spcPts val="600"/>
+                <a:spcPts val="700"/>
               </a:spcAft>
             </a:pPr>
             <a:r>
-              <a:rPr b="1" sz="1100">
+              <a:rPr b="1" sz="1250">
                 <a:solidFill>
                   <a:srgbClr val="102C57"/>
                 </a:solidFill>
@@ -19403,7 +19403,7 @@
               <a:t>Objective 3 -- Multi-Source Evidence Retrieval: </a:t>
             </a:r>
             <a:r>
-              <a:rPr sz="1100">
+              <a:rPr sz="1250">
                 <a:solidFill>
                   <a:srgbClr val="212529"/>
                 </a:solidFill>
@@ -19414,11 +19414,11 @@
           <a:p>
             <a:pPr>
               <a:spcAft>
-                <a:spcPts val="600"/>
+                <a:spcPts val="700"/>
               </a:spcAft>
             </a:pPr>
             <a:r>
-              <a:rPr b="1" sz="1100">
+              <a:rPr b="1" sz="1250">
                 <a:solidFill>
                   <a:srgbClr val="102C57"/>
                 </a:solidFill>
@@ -19426,7 +19426,7 @@
               <a:t>Objective 4 -- RoBERTa-MNLI Cross-Source Corroboration: </a:t>
             </a:r>
             <a:r>
-              <a:rPr sz="1100">
+              <a:rPr sz="1250">
                 <a:solidFill>
                   <a:srgbClr val="212529"/>
                 </a:solidFill>
@@ -19437,11 +19437,11 @@
           <a:p>
             <a:pPr>
               <a:spcAft>
-                <a:spcPts val="600"/>
+                <a:spcPts val="700"/>
               </a:spcAft>
             </a:pPr>
             <a:r>
-              <a:rPr b="1" sz="1100">
+              <a:rPr b="1" sz="1250">
                 <a:solidFill>
                   <a:srgbClr val="102C57"/>
                 </a:solidFill>
@@ -19449,7 +19449,7 @@
               <a:t>Objective 5 -- Manipulation &amp; Clickbait Indexing: </a:t>
             </a:r>
             <a:r>
-              <a:rPr sz="1100">
+              <a:rPr sz="1250">
                 <a:solidFill>
                   <a:srgbClr val="212529"/>
                 </a:solidFill>
@@ -19460,11 +19460,11 @@
           <a:p>
             <a:pPr>
               <a:spcAft>
-                <a:spcPts val="600"/>
+                <a:spcPts val="700"/>
               </a:spcAft>
             </a:pPr>
             <a:r>
-              <a:rPr b="1" sz="1100">
+              <a:rPr b="1" sz="1250">
                 <a:solidFill>
                   <a:srgbClr val="102C57"/>
                 </a:solidFill>
@@ -19472,7 +19472,7 @@
               <a:t>Objective 6 -- Unified Aggregation Engine &amp; User Interface: </a:t>
             </a:r>
             <a:r>
-              <a:rPr sz="1100">
+              <a:rPr sz="1250">
                 <a:solidFill>
                   <a:srgbClr val="212529"/>
                 </a:solidFill>
@@ -19521,7 +19521,7 @@
         <p:spPr>
           <a:xfrm>
             <a:off x="731520" y="365760"/>
-            <a:ext cx="10515600" cy="822960"/>
+            <a:ext cx="10789920" cy="822960"/>
           </a:xfrm>
           <a:prstGeom prst="rect">
             <a:avLst/>
@@ -19535,7 +19535,7 @@
           <a:lstStyle/>
           <a:p>
             <a:pPr>
-              <a:defRPr sz="2400" b="1">
+              <a:defRPr sz="2600" b="1">
                 <a:solidFill>
                   <a:srgbClr val="102C57"/>
                 </a:solidFill>
@@ -19543,7 +19543,7 @@
               </a:defRPr>
             </a:pPr>
             <a:r>
-              <a:t>Existing Methods and Drawbacks (Rubric: 2 Marks)</a:t>
+              <a:t>Existing Methods and Drawbacks</a:t>
             </a:r>
           </a:p>
         </p:txBody>
@@ -19558,7 +19558,7 @@
         </p:nvGraphicFramePr>
         <p:xfrm>
           <a:off x="731520" y="1188720"/>
-          <a:ext cx="10515600" cy="5029200"/>
+          <a:ext cx="10789920" cy="5120640"/>
         </p:xfrm>
         <a:graphic>
           <a:graphicData uri="http://schemas.openxmlformats.org/drawingml/2006/table">
@@ -19569,16 +19569,16 @@
               <a:tblGrid>
                 <a:gridCol w="2560320"/>
                 <a:gridCol w="2926080"/>
-                <a:gridCol w="5029200"/>
+                <a:gridCol w="5303520"/>
               </a:tblGrid>
-              <a:tr h="1005840">
+              <a:tr h="1024128">
                 <a:tc>
                   <a:txBody>
                     <a:bodyPr/>
                     <a:lstStyle/>
                     <a:p>
                       <a:pPr algn="l">
-                        <a:defRPr sz="1100" b="1">
+                        <a:defRPr sz="1200" b="1">
                           <a:solidFill>
                             <a:srgbClr val="FFFFFF"/>
                           </a:solidFill>
@@ -19602,7 +19602,7 @@
                     <a:lstStyle/>
                     <a:p>
                       <a:pPr algn="l">
-                        <a:defRPr sz="1100" b="1">
+                        <a:defRPr sz="1200" b="1">
                           <a:solidFill>
                             <a:srgbClr val="FFFFFF"/>
                           </a:solidFill>
@@ -19626,7 +19626,7 @@
                     <a:lstStyle/>
                     <a:p>
                       <a:pPr algn="l">
-                        <a:defRPr sz="1100" b="1">
+                        <a:defRPr sz="1200" b="1">
                           <a:solidFill>
                             <a:srgbClr val="FFFFFF"/>
                           </a:solidFill>
@@ -19645,14 +19645,14 @@
                   </a:tcPr>
                 </a:tc>
               </a:tr>
-              <a:tr h="1005840">
+              <a:tr h="1024128">
                 <a:tc>
                   <a:txBody>
                     <a:bodyPr/>
                     <a:lstStyle/>
                     <a:p>
                       <a:pPr algn="l">
-                        <a:defRPr sz="1000" b="0">
+                        <a:defRPr sz="1100" b="0">
                           <a:solidFill>
                             <a:srgbClr val="212529"/>
                           </a:solidFill>
@@ -19681,7 +19681,7 @@
                     <a:lstStyle/>
                     <a:p>
                       <a:pPr algn="l">
-                        <a:defRPr sz="1000" b="0">
+                        <a:defRPr sz="1100" b="0">
                           <a:solidFill>
                             <a:srgbClr val="212529"/>
                           </a:solidFill>
@@ -19705,7 +19705,7 @@
                     <a:lstStyle/>
                     <a:p>
                       <a:pPr algn="l">
-                        <a:defRPr sz="1000" b="0">
+                        <a:defRPr sz="1100" b="0">
                           <a:solidFill>
                             <a:srgbClr val="212529"/>
                           </a:solidFill>
@@ -19724,14 +19724,14 @@
                   </a:tcPr>
                 </a:tc>
               </a:tr>
-              <a:tr h="1005840">
+              <a:tr h="1024128">
                 <a:tc>
                   <a:txBody>
                     <a:bodyPr/>
                     <a:lstStyle/>
                     <a:p>
                       <a:pPr algn="l">
-                        <a:defRPr sz="1000" b="0">
+                        <a:defRPr sz="1100" b="0">
                           <a:solidFill>
                             <a:srgbClr val="212529"/>
                           </a:solidFill>
@@ -19751,7 +19751,7 @@
                     <a:lstStyle/>
                     <a:p>
                       <a:pPr algn="l">
-                        <a:defRPr sz="1000" b="0">
+                        <a:defRPr sz="1100" b="0">
                           <a:solidFill>
                             <a:srgbClr val="212529"/>
                           </a:solidFill>
@@ -19771,7 +19771,7 @@
                     <a:lstStyle/>
                     <a:p>
                       <a:pPr algn="l">
-                        <a:defRPr sz="1000" b="0">
+                        <a:defRPr sz="1100" b="0">
                           <a:solidFill>
                             <a:srgbClr val="212529"/>
                           </a:solidFill>
@@ -19786,14 +19786,14 @@
                   <a:tcPr marL="73152" marR="73152" marT="45720" marB="45720" anchor="ctr"/>
                 </a:tc>
               </a:tr>
-              <a:tr h="1005840">
+              <a:tr h="1024128">
                 <a:tc>
                   <a:txBody>
                     <a:bodyPr/>
                     <a:lstStyle/>
                     <a:p>
                       <a:pPr algn="l">
-                        <a:defRPr sz="1000" b="0">
+                        <a:defRPr sz="1100" b="0">
                           <a:solidFill>
                             <a:srgbClr val="212529"/>
                           </a:solidFill>
@@ -19822,7 +19822,7 @@
                     <a:lstStyle/>
                     <a:p>
                       <a:pPr algn="l">
-                        <a:defRPr sz="1000" b="0">
+                        <a:defRPr sz="1100" b="0">
                           <a:solidFill>
                             <a:srgbClr val="212529"/>
                           </a:solidFill>
@@ -19846,7 +19846,7 @@
                     <a:lstStyle/>
                     <a:p>
                       <a:pPr algn="l">
-                        <a:defRPr sz="1000" b="0">
+                        <a:defRPr sz="1100" b="0">
                           <a:solidFill>
                             <a:srgbClr val="212529"/>
                           </a:solidFill>
@@ -19865,14 +19865,14 @@
                   </a:tcPr>
                 </a:tc>
               </a:tr>
-              <a:tr h="1005840">
+              <a:tr h="1024128">
                 <a:tc>
                   <a:txBody>
                     <a:bodyPr/>
                     <a:lstStyle/>
                     <a:p>
                       <a:pPr algn="l">
-                        <a:defRPr sz="1000" b="0">
+                        <a:defRPr sz="1100" b="0">
                           <a:solidFill>
                             <a:srgbClr val="212529"/>
                           </a:solidFill>
@@ -19892,7 +19892,7 @@
                     <a:lstStyle/>
                     <a:p>
                       <a:pPr algn="l">
-                        <a:defRPr sz="1000" b="0">
+                        <a:defRPr sz="1100" b="0">
                           <a:solidFill>
                             <a:srgbClr val="212529"/>
                           </a:solidFill>
@@ -19912,7 +19912,7 @@
                     <a:lstStyle/>
                     <a:p>
                       <a:pPr algn="l">
-                        <a:defRPr sz="1000" b="0">
+                        <a:defRPr sz="1100" b="0">
                           <a:solidFill>
                             <a:srgbClr val="212529"/>
                           </a:solidFill>

</xml_diff>